<commit_message>
Nettoyage du dossier doc : suppression des anciennes versions et conservation des fichiers renommés
</commit_message>
<xml_diff>
--- a/2-Analyse exploratoire des données/2-Steam/doc/Project_Steam_Storytelling.pptx
+++ b/2-Analyse exploratoire des données/2-Steam/doc/Project_Steam_Storytelling.pptx
@@ -8,10 +8,13 @@
     <p:sldId id="256" r:id="rId2"/>
     <p:sldId id="257" r:id="rId3"/>
     <p:sldId id="258" r:id="rId4"/>
+    <p:sldId id="265" r:id="rId16"/>
     <p:sldId id="259" r:id="rId5"/>
+    <p:sldId id="266" r:id="rId17"/>
     <p:sldId id="260" r:id="rId6"/>
     <p:sldId id="261" r:id="rId7"/>
     <p:sldId id="262" r:id="rId8"/>
+    <p:sldId id="267" r:id="rId18"/>
     <p:sldId id="263" r:id="rId9"/>
     <p:sldId id="264" r:id="rId10"/>
   </p:sldIdLst>
@@ -1632,6 +1635,10 @@
           </a:solidFill>
           <a:ln/>
         </p:spPr>
+        <p:txBody>
+          <a:bodyPr/>
+          <a:p/>
+        </p:txBody>
       </p:sp>
       <p:sp>
         <p:nvSpPr>
@@ -1744,7 +1751,7 @@
                 <a:ea typeface="Arial" pitchFamily="34" charset="-122"/>
                 <a:cs typeface="Arial" pitchFamily="34" charset="-120"/>
               </a:rPr>
-              <a:t>Plateforme de jeux video</a:t>
+              <a:t>Plateforme de jeux vidéo</a:t>
             </a:r>
             <a:endParaRPr lang="en-US" sz="2000" dirty="0"/>
           </a:p>
@@ -1769,6 +1776,10 @@
           </a:solidFill>
           <a:ln/>
         </p:spPr>
+        <p:txBody>
+          <a:bodyPr/>
+          <a:p/>
+        </p:txBody>
       </p:sp>
       <p:sp>
         <p:nvSpPr>
@@ -1833,6 +1844,10 @@
             <a:prstDash val="solid"/>
           </a:ln>
         </p:spPr>
+        <p:txBody>
+          <a:bodyPr/>
+          <a:p/>
+        </p:txBody>
       </p:sp>
       <p:sp>
         <p:nvSpPr>
@@ -1936,6 +1951,10 @@
             <a:prstDash val="solid"/>
           </a:ln>
         </p:spPr>
+        <p:txBody>
+          <a:bodyPr/>
+          <a:p/>
+        </p:txBody>
       </p:sp>
       <p:sp>
         <p:nvSpPr>
@@ -2039,6 +2058,10 @@
             <a:prstDash val="solid"/>
           </a:ln>
         </p:spPr>
+        <p:txBody>
+          <a:bodyPr/>
+          <a:p/>
+        </p:txBody>
       </p:sp>
       <p:sp>
         <p:nvSpPr>
@@ -2142,6 +2165,10 @@
             <a:prstDash val="solid"/>
           </a:ln>
         </p:spPr>
+        <p:txBody>
+          <a:bodyPr/>
+          <a:p/>
+        </p:txBody>
       </p:sp>
       <p:pic>
         <p:nvPicPr>
@@ -2167,6 +2194,4354 @@
           </a:prstGeom>
         </p:spPr>
       </p:pic>
+    </p:spTree>
+  </p:cSld>
+  <p:clrMapOvr>
+    <a:masterClrMapping/>
+  </p:clrMapOvr>
+</p:sld>
+</file>
+
+<file path=ppt/slides/slide10.xml><?xml version="1.0" encoding="utf-8"?>
+<p:sld xmlns:a="http://schemas.openxmlformats.org/drawingml/2006/main" xmlns:p="http://schemas.openxmlformats.org/presentationml/2006/main" xmlns:r="http://schemas.openxmlformats.org/officeDocument/2006/relationships">
+  <p:cSld>
+    <p:spTree>
+      <p:nvGrpSpPr>
+        <p:cNvPr id="1" name=""/>
+        <p:cNvGrpSpPr/>
+        <p:nvPr/>
+      </p:nvGrpSpPr>
+      <p:grpSpPr/>
+      <p:sp>
+        <p:nvSpPr>
+          <p:cNvPr id="2" name="TextBox 1"/>
+          <p:cNvSpPr txBox="1"/>
+          <p:nvPr/>
+        </p:nvSpPr>
+        <p:spPr>
+          <a:xfrm>
+            <a:off x="457200" y="256032"/>
+            <a:ext cx="7772400" cy="274320"/>
+          </a:xfrm>
+          <a:prstGeom prst="rect">
+            <a:avLst/>
+          </a:prstGeom>
+          <a:noFill/>
+        </p:spPr>
+        <p:txBody>
+          <a:bodyPr wrap="square" lIns="0" rIns="0" tIns="0" bIns="0" anchor="t">
+            <a:spAutoFit/>
+          </a:bodyPr>
+          <a:lstStyle/>
+          <a:p>
+            <a:pPr algn="l"/>
+            <a:r>
+              <a:rPr sz="1100" b="1" i="0">
+                <a:solidFill>
+                  <a:srgbClr val="EF3E5C"/>
+                </a:solidFill>
+                <a:latin typeface="Arial"/>
+              </a:rPr>
+              <a:t>A N A L Y S E   M A C R O   -   2 / 5</a:t>
+            </a:r>
+          </a:p>
+        </p:txBody>
+      </p:sp>
+      <p:sp>
+        <p:nvSpPr>
+          <p:cNvPr id="3" name="TextBox 2"/>
+          <p:cNvSpPr txBox="1"/>
+          <p:nvPr/>
+        </p:nvSpPr>
+        <p:spPr>
+          <a:xfrm>
+            <a:off x="420624" y="502920"/>
+            <a:ext cx="8229600" cy="777240"/>
+          </a:xfrm>
+          <a:prstGeom prst="rect">
+            <a:avLst/>
+          </a:prstGeom>
+          <a:noFill/>
+        </p:spPr>
+        <p:txBody>
+          <a:bodyPr wrap="square" lIns="0" rIns="0" tIns="0" bIns="0" anchor="t">
+            <a:spAutoFit/>
+          </a:bodyPr>
+          <a:lstStyle/>
+          <a:p>
+            <a:pPr algn="l"/>
+            <a:r>
+              <a:rPr sz="3400" b="1" i="0">
+                <a:solidFill>
+                  <a:srgbClr val="FFFFFF"/>
+                </a:solidFill>
+                <a:latin typeface="Arial Black"/>
+              </a:rPr>
+              <a:t>Les jeux les mieux notés</a:t>
+            </a:r>
+          </a:p>
+        </p:txBody>
+      </p:sp>
+      <p:sp>
+        <p:nvSpPr>
+          <p:cNvPr id="4" name="TextBox 3"/>
+          <p:cNvSpPr txBox="1"/>
+          <p:nvPr/>
+        </p:nvSpPr>
+        <p:spPr>
+          <a:xfrm>
+            <a:off x="457200" y="1325880"/>
+            <a:ext cx="4572000" cy="274320"/>
+          </a:xfrm>
+          <a:prstGeom prst="rect">
+            <a:avLst/>
+          </a:prstGeom>
+          <a:noFill/>
+        </p:spPr>
+        <p:txBody>
+          <a:bodyPr wrap="square" lIns="0" rIns="0" tIns="0" bIns="0" anchor="t">
+            <a:spAutoFit/>
+          </a:bodyPr>
+          <a:lstStyle/>
+          <a:p>
+            <a:pPr algn="l"/>
+            <a:r>
+              <a:rPr sz="1300" b="1" i="0">
+                <a:solidFill>
+                  <a:srgbClr val="29A9E0"/>
+                </a:solidFill>
+                <a:latin typeface="Arial"/>
+              </a:rPr>
+              <a:t>Top des ratios d'avis positifs</a:t>
+            </a:r>
+          </a:p>
+        </p:txBody>
+      </p:sp>
+      <p:sp>
+        <p:nvSpPr>
+          <p:cNvPr id="5" name="Rounded Rectangle 4"/>
+          <p:cNvSpPr/>
+          <p:nvPr/>
+        </p:nvSpPr>
+        <p:spPr>
+          <a:xfrm>
+            <a:off x="457200" y="1645920"/>
+            <a:ext cx="4754880" cy="2880360"/>
+          </a:xfrm>
+          <a:prstGeom prst="roundRect">
+            <a:avLst>
+              <a:gd name="adj" fmla="val 5000"/>
+            </a:avLst>
+          </a:prstGeom>
+          <a:solidFill>
+            <a:srgbClr val="16263F"/>
+          </a:solidFill>
+          <a:ln w="12700">
+            <a:solidFill>
+              <a:srgbClr val="24344F"/>
+            </a:solidFill>
+          </a:ln>
+          <a:effectLst/>
+        </p:spPr>
+        <p:style>
+          <a:lnRef idx="1">
+            <a:schemeClr val="accent1"/>
+          </a:lnRef>
+          <a:fillRef idx="3">
+            <a:schemeClr val="accent1"/>
+          </a:fillRef>
+          <a:effectRef idx="2">
+            <a:schemeClr val="accent1"/>
+          </a:effectRef>
+          <a:fontRef idx="minor">
+            <a:schemeClr val="lt1"/>
+          </a:fontRef>
+        </p:style>
+        <p:txBody>
+          <a:bodyPr rtlCol="0" anchor="ctr"/>
+          <a:lstStyle/>
+          <a:p>
+            <a:pPr algn="ctr"/>
+          </a:p>
+        </p:txBody>
+      </p:sp>
+      <p:sp>
+        <p:nvSpPr>
+          <p:cNvPr id="6" name="TextBox 5"/>
+          <p:cNvSpPr txBox="1"/>
+          <p:nvPr/>
+        </p:nvSpPr>
+        <p:spPr>
+          <a:xfrm>
+            <a:off x="658368" y="1883664"/>
+            <a:ext cx="320040" cy="274320"/>
+          </a:xfrm>
+          <a:prstGeom prst="rect">
+            <a:avLst/>
+          </a:prstGeom>
+          <a:noFill/>
+        </p:spPr>
+        <p:txBody>
+          <a:bodyPr wrap="square" lIns="0" rIns="0" tIns="0" bIns="0" anchor="t">
+            <a:spAutoFit/>
+          </a:bodyPr>
+          <a:lstStyle/>
+          <a:p>
+            <a:pPr algn="l"/>
+            <a:r>
+              <a:rPr sz="1200" b="1" i="0">
+                <a:solidFill>
+                  <a:srgbClr val="29A9E0"/>
+                </a:solidFill>
+                <a:latin typeface="Arial Black"/>
+              </a:rPr>
+              <a:t>1</a:t>
+            </a:r>
+          </a:p>
+        </p:txBody>
+      </p:sp>
+      <p:sp>
+        <p:nvSpPr>
+          <p:cNvPr id="7" name="TextBox 6"/>
+          <p:cNvSpPr txBox="1"/>
+          <p:nvPr/>
+        </p:nvSpPr>
+        <p:spPr>
+          <a:xfrm>
+            <a:off x="1051560" y="1883664"/>
+            <a:ext cx="2651760" cy="274320"/>
+          </a:xfrm>
+          <a:prstGeom prst="rect">
+            <a:avLst/>
+          </a:prstGeom>
+          <a:noFill/>
+        </p:spPr>
+        <p:txBody>
+          <a:bodyPr wrap="square" lIns="0" rIns="0" tIns="0" bIns="0" anchor="t">
+            <a:spAutoFit/>
+          </a:bodyPr>
+          <a:lstStyle/>
+          <a:p>
+            <a:pPr algn="l"/>
+            <a:r>
+              <a:rPr sz="1050" b="0" i="0">
+                <a:solidFill>
+                  <a:srgbClr val="FFFFFF"/>
+                </a:solidFill>
+                <a:latin typeface="Arial"/>
+              </a:rPr>
+              <a:t>Secret Sealing Travel</a:t>
+            </a:r>
+          </a:p>
+        </p:txBody>
+      </p:sp>
+      <p:sp>
+        <p:nvSpPr>
+          <p:cNvPr id="8" name="TextBox 7"/>
+          <p:cNvSpPr txBox="1"/>
+          <p:nvPr/>
+        </p:nvSpPr>
+        <p:spPr>
+          <a:xfrm>
+            <a:off x="3794760" y="1883664"/>
+            <a:ext cx="1234440" cy="274320"/>
+          </a:xfrm>
+          <a:prstGeom prst="rect">
+            <a:avLst/>
+          </a:prstGeom>
+          <a:noFill/>
+        </p:spPr>
+        <p:txBody>
+          <a:bodyPr wrap="square" lIns="0" rIns="0" tIns="0" bIns="0" anchor="t">
+            <a:spAutoFit/>
+          </a:bodyPr>
+          <a:lstStyle/>
+          <a:p>
+            <a:pPr algn="r"/>
+            <a:r>
+              <a:rPr sz="1000" b="0" i="0">
+                <a:solidFill>
+                  <a:srgbClr val="9AA3B2"/>
+                </a:solidFill>
+                <a:latin typeface="Arial"/>
+              </a:rPr>
+              <a:t>218 avis</a:t>
+            </a:r>
+          </a:p>
+        </p:txBody>
+      </p:sp>
+      <p:sp>
+        <p:nvSpPr>
+          <p:cNvPr id="9" name="TextBox 8"/>
+          <p:cNvSpPr txBox="1"/>
+          <p:nvPr/>
+        </p:nvSpPr>
+        <p:spPr>
+          <a:xfrm>
+            <a:off x="658368" y="2313432"/>
+            <a:ext cx="320040" cy="274320"/>
+          </a:xfrm>
+          <a:prstGeom prst="rect">
+            <a:avLst/>
+          </a:prstGeom>
+          <a:noFill/>
+        </p:spPr>
+        <p:txBody>
+          <a:bodyPr wrap="square" lIns="0" rIns="0" tIns="0" bIns="0" anchor="t">
+            <a:spAutoFit/>
+          </a:bodyPr>
+          <a:lstStyle/>
+          <a:p>
+            <a:pPr algn="l"/>
+            <a:r>
+              <a:rPr sz="1200" b="1" i="0">
+                <a:solidFill>
+                  <a:srgbClr val="29A9E0"/>
+                </a:solidFill>
+                <a:latin typeface="Arial Black"/>
+              </a:rPr>
+              <a:t>2</a:t>
+            </a:r>
+          </a:p>
+        </p:txBody>
+      </p:sp>
+      <p:sp>
+        <p:nvSpPr>
+          <p:cNvPr id="10" name="TextBox 9"/>
+          <p:cNvSpPr txBox="1"/>
+          <p:nvPr/>
+        </p:nvSpPr>
+        <p:spPr>
+          <a:xfrm>
+            <a:off x="1051560" y="2313432"/>
+            <a:ext cx="2651760" cy="274320"/>
+          </a:xfrm>
+          <a:prstGeom prst="rect">
+            <a:avLst/>
+          </a:prstGeom>
+          <a:noFill/>
+        </p:spPr>
+        <p:txBody>
+          <a:bodyPr wrap="square" lIns="0" rIns="0" tIns="0" bIns="0" anchor="t">
+            <a:spAutoFit/>
+          </a:bodyPr>
+          <a:lstStyle/>
+          <a:p>
+            <a:pPr algn="l"/>
+            <a:r>
+              <a:rPr sz="1050" b="0" i="0">
+                <a:solidFill>
+                  <a:srgbClr val="FFFFFF"/>
+                </a:solidFill>
+                <a:latin typeface="Arial"/>
+              </a:rPr>
+              <a:t>Elasto Mania Remastered</a:t>
+            </a:r>
+          </a:p>
+        </p:txBody>
+      </p:sp>
+      <p:sp>
+        <p:nvSpPr>
+          <p:cNvPr id="11" name="TextBox 10"/>
+          <p:cNvSpPr txBox="1"/>
+          <p:nvPr/>
+        </p:nvSpPr>
+        <p:spPr>
+          <a:xfrm>
+            <a:off x="3794760" y="2313432"/>
+            <a:ext cx="1234440" cy="274320"/>
+          </a:xfrm>
+          <a:prstGeom prst="rect">
+            <a:avLst/>
+          </a:prstGeom>
+          <a:noFill/>
+        </p:spPr>
+        <p:txBody>
+          <a:bodyPr wrap="square" lIns="0" rIns="0" tIns="0" bIns="0" anchor="t">
+            <a:spAutoFit/>
+          </a:bodyPr>
+          <a:lstStyle/>
+          <a:p>
+            <a:pPr algn="r"/>
+            <a:r>
+              <a:rPr sz="1000" b="0" i="0">
+                <a:solidFill>
+                  <a:srgbClr val="9AA3B2"/>
+                </a:solidFill>
+                <a:latin typeface="Arial"/>
+              </a:rPr>
+              <a:t>190 avis</a:t>
+            </a:r>
+          </a:p>
+        </p:txBody>
+      </p:sp>
+      <p:sp>
+        <p:nvSpPr>
+          <p:cNvPr id="12" name="TextBox 11"/>
+          <p:cNvSpPr txBox="1"/>
+          <p:nvPr/>
+        </p:nvSpPr>
+        <p:spPr>
+          <a:xfrm>
+            <a:off x="658368" y="2743200"/>
+            <a:ext cx="320040" cy="274320"/>
+          </a:xfrm>
+          <a:prstGeom prst="rect">
+            <a:avLst/>
+          </a:prstGeom>
+          <a:noFill/>
+        </p:spPr>
+        <p:txBody>
+          <a:bodyPr wrap="square" lIns="0" rIns="0" tIns="0" bIns="0" anchor="t">
+            <a:spAutoFit/>
+          </a:bodyPr>
+          <a:lstStyle/>
+          <a:p>
+            <a:pPr algn="l"/>
+            <a:r>
+              <a:rPr sz="1200" b="1" i="0">
+                <a:solidFill>
+                  <a:srgbClr val="29A9E0"/>
+                </a:solidFill>
+                <a:latin typeface="Arial Black"/>
+              </a:rPr>
+              <a:t>3</a:t>
+            </a:r>
+          </a:p>
+        </p:txBody>
+      </p:sp>
+      <p:sp>
+        <p:nvSpPr>
+          <p:cNvPr id="13" name="TextBox 12"/>
+          <p:cNvSpPr txBox="1"/>
+          <p:nvPr/>
+        </p:nvSpPr>
+        <p:spPr>
+          <a:xfrm>
+            <a:off x="1051560" y="2743200"/>
+            <a:ext cx="2651760" cy="274320"/>
+          </a:xfrm>
+          <a:prstGeom prst="rect">
+            <a:avLst/>
+          </a:prstGeom>
+          <a:noFill/>
+        </p:spPr>
+        <p:txBody>
+          <a:bodyPr wrap="square" lIns="0" rIns="0" tIns="0" bIns="0" anchor="t">
+            <a:spAutoFit/>
+          </a:bodyPr>
+          <a:lstStyle/>
+          <a:p>
+            <a:pPr algn="l"/>
+            <a:r>
+              <a:rPr sz="1050" b="0" i="0">
+                <a:solidFill>
+                  <a:srgbClr val="FFFFFF"/>
+                </a:solidFill>
+                <a:latin typeface="Arial"/>
+              </a:rPr>
+              <a:t>Freshly Frosted</a:t>
+            </a:r>
+          </a:p>
+        </p:txBody>
+      </p:sp>
+      <p:sp>
+        <p:nvSpPr>
+          <p:cNvPr id="14" name="TextBox 13"/>
+          <p:cNvSpPr txBox="1"/>
+          <p:nvPr/>
+        </p:nvSpPr>
+        <p:spPr>
+          <a:xfrm>
+            <a:off x="3794760" y="2743200"/>
+            <a:ext cx="1234440" cy="274320"/>
+          </a:xfrm>
+          <a:prstGeom prst="rect">
+            <a:avLst/>
+          </a:prstGeom>
+          <a:noFill/>
+        </p:spPr>
+        <p:txBody>
+          <a:bodyPr wrap="square" lIns="0" rIns="0" tIns="0" bIns="0" anchor="t">
+            <a:spAutoFit/>
+          </a:bodyPr>
+          <a:lstStyle/>
+          <a:p>
+            <a:pPr algn="r"/>
+            <a:r>
+              <a:rPr sz="1000" b="0" i="0">
+                <a:solidFill>
+                  <a:srgbClr val="9AA3B2"/>
+                </a:solidFill>
+                <a:latin typeface="Arial"/>
+              </a:rPr>
+              <a:t>157 avis</a:t>
+            </a:r>
+          </a:p>
+        </p:txBody>
+      </p:sp>
+      <p:sp>
+        <p:nvSpPr>
+          <p:cNvPr id="15" name="TextBox 14"/>
+          <p:cNvSpPr txBox="1"/>
+          <p:nvPr/>
+        </p:nvSpPr>
+        <p:spPr>
+          <a:xfrm>
+            <a:off x="658368" y="3172968"/>
+            <a:ext cx="320040" cy="274320"/>
+          </a:xfrm>
+          <a:prstGeom prst="rect">
+            <a:avLst/>
+          </a:prstGeom>
+          <a:noFill/>
+        </p:spPr>
+        <p:txBody>
+          <a:bodyPr wrap="square" lIns="0" rIns="0" tIns="0" bIns="0" anchor="t">
+            <a:spAutoFit/>
+          </a:bodyPr>
+          <a:lstStyle/>
+          <a:p>
+            <a:pPr algn="l"/>
+            <a:r>
+              <a:rPr sz="1200" b="1" i="0">
+                <a:solidFill>
+                  <a:srgbClr val="29A9E0"/>
+                </a:solidFill>
+                <a:latin typeface="Arial Black"/>
+              </a:rPr>
+              <a:t>4</a:t>
+            </a:r>
+          </a:p>
+        </p:txBody>
+      </p:sp>
+      <p:sp>
+        <p:nvSpPr>
+          <p:cNvPr id="16" name="TextBox 15"/>
+          <p:cNvSpPr txBox="1"/>
+          <p:nvPr/>
+        </p:nvSpPr>
+        <p:spPr>
+          <a:xfrm>
+            <a:off x="1051560" y="3172968"/>
+            <a:ext cx="2651760" cy="274320"/>
+          </a:xfrm>
+          <a:prstGeom prst="rect">
+            <a:avLst/>
+          </a:prstGeom>
+          <a:noFill/>
+        </p:spPr>
+        <p:txBody>
+          <a:bodyPr wrap="square" lIns="0" rIns="0" tIns="0" bIns="0" anchor="t">
+            <a:spAutoFit/>
+          </a:bodyPr>
+          <a:lstStyle/>
+          <a:p>
+            <a:pPr algn="l"/>
+            <a:r>
+              <a:rPr sz="1050" b="0" i="0">
+                <a:solidFill>
+                  <a:srgbClr val="FFFFFF"/>
+                </a:solidFill>
+                <a:latin typeface="Arial"/>
+              </a:rPr>
+              <a:t>FIND ALL 2: Middle Ages</a:t>
+            </a:r>
+          </a:p>
+        </p:txBody>
+      </p:sp>
+      <p:sp>
+        <p:nvSpPr>
+          <p:cNvPr id="17" name="TextBox 16"/>
+          <p:cNvSpPr txBox="1"/>
+          <p:nvPr/>
+        </p:nvSpPr>
+        <p:spPr>
+          <a:xfrm>
+            <a:off x="3794760" y="3172968"/>
+            <a:ext cx="1234440" cy="274320"/>
+          </a:xfrm>
+          <a:prstGeom prst="rect">
+            <a:avLst/>
+          </a:prstGeom>
+          <a:noFill/>
+        </p:spPr>
+        <p:txBody>
+          <a:bodyPr wrap="square" lIns="0" rIns="0" tIns="0" bIns="0" anchor="t">
+            <a:spAutoFit/>
+          </a:bodyPr>
+          <a:lstStyle/>
+          <a:p>
+            <a:pPr algn="r"/>
+            <a:r>
+              <a:rPr sz="1000" b="0" i="0">
+                <a:solidFill>
+                  <a:srgbClr val="9AA3B2"/>
+                </a:solidFill>
+                <a:latin typeface="Arial"/>
+              </a:rPr>
+              <a:t>132 avis</a:t>
+            </a:r>
+          </a:p>
+        </p:txBody>
+      </p:sp>
+      <p:sp>
+        <p:nvSpPr>
+          <p:cNvPr id="18" name="TextBox 17"/>
+          <p:cNvSpPr txBox="1"/>
+          <p:nvPr/>
+        </p:nvSpPr>
+        <p:spPr>
+          <a:xfrm>
+            <a:off x="658368" y="3602735"/>
+            <a:ext cx="320040" cy="274320"/>
+          </a:xfrm>
+          <a:prstGeom prst="rect">
+            <a:avLst/>
+          </a:prstGeom>
+          <a:noFill/>
+        </p:spPr>
+        <p:txBody>
+          <a:bodyPr wrap="square" lIns="0" rIns="0" tIns="0" bIns="0" anchor="t">
+            <a:spAutoFit/>
+          </a:bodyPr>
+          <a:lstStyle/>
+          <a:p>
+            <a:pPr algn="l"/>
+            <a:r>
+              <a:rPr sz="1200" b="1" i="0">
+                <a:solidFill>
+                  <a:srgbClr val="29A9E0"/>
+                </a:solidFill>
+                <a:latin typeface="Arial Black"/>
+              </a:rPr>
+              <a:t>5</a:t>
+            </a:r>
+          </a:p>
+        </p:txBody>
+      </p:sp>
+      <p:sp>
+        <p:nvSpPr>
+          <p:cNvPr id="19" name="TextBox 18"/>
+          <p:cNvSpPr txBox="1"/>
+          <p:nvPr/>
+        </p:nvSpPr>
+        <p:spPr>
+          <a:xfrm>
+            <a:off x="1051560" y="3602735"/>
+            <a:ext cx="2651760" cy="274320"/>
+          </a:xfrm>
+          <a:prstGeom prst="rect">
+            <a:avLst/>
+          </a:prstGeom>
+          <a:noFill/>
+        </p:spPr>
+        <p:txBody>
+          <a:bodyPr wrap="square" lIns="0" rIns="0" tIns="0" bIns="0" anchor="t">
+            <a:spAutoFit/>
+          </a:bodyPr>
+          <a:lstStyle/>
+          <a:p>
+            <a:pPr algn="l"/>
+            <a:r>
+              <a:rPr sz="1050" b="0" i="0">
+                <a:solidFill>
+                  <a:srgbClr val="FFFFFF"/>
+                </a:solidFill>
+                <a:latin typeface="Arial"/>
+              </a:rPr>
+              <a:t>Phantasmagoria of Flower View</a:t>
+            </a:r>
+          </a:p>
+        </p:txBody>
+      </p:sp>
+      <p:sp>
+        <p:nvSpPr>
+          <p:cNvPr id="20" name="TextBox 19"/>
+          <p:cNvSpPr txBox="1"/>
+          <p:nvPr/>
+        </p:nvSpPr>
+        <p:spPr>
+          <a:xfrm>
+            <a:off x="3794760" y="3602735"/>
+            <a:ext cx="1234440" cy="274320"/>
+          </a:xfrm>
+          <a:prstGeom prst="rect">
+            <a:avLst/>
+          </a:prstGeom>
+          <a:noFill/>
+        </p:spPr>
+        <p:txBody>
+          <a:bodyPr wrap="square" lIns="0" rIns="0" tIns="0" bIns="0" anchor="t">
+            <a:spAutoFit/>
+          </a:bodyPr>
+          <a:lstStyle/>
+          <a:p>
+            <a:pPr algn="r"/>
+            <a:r>
+              <a:rPr sz="1000" b="0" i="0">
+                <a:solidFill>
+                  <a:srgbClr val="9AA3B2"/>
+                </a:solidFill>
+                <a:latin typeface="Arial"/>
+              </a:rPr>
+              <a:t>119 avis</a:t>
+            </a:r>
+          </a:p>
+        </p:txBody>
+      </p:sp>
+      <p:sp>
+        <p:nvSpPr>
+          <p:cNvPr id="21" name="TextBox 20"/>
+          <p:cNvSpPr txBox="1"/>
+          <p:nvPr/>
+        </p:nvSpPr>
+        <p:spPr>
+          <a:xfrm>
+            <a:off x="658368" y="4032503"/>
+            <a:ext cx="320040" cy="274320"/>
+          </a:xfrm>
+          <a:prstGeom prst="rect">
+            <a:avLst/>
+          </a:prstGeom>
+          <a:noFill/>
+        </p:spPr>
+        <p:txBody>
+          <a:bodyPr wrap="square" lIns="0" rIns="0" tIns="0" bIns="0" anchor="t">
+            <a:spAutoFit/>
+          </a:bodyPr>
+          <a:lstStyle/>
+          <a:p>
+            <a:pPr algn="l"/>
+            <a:r>
+              <a:rPr sz="1200" b="1" i="0">
+                <a:solidFill>
+                  <a:srgbClr val="29A9E0"/>
+                </a:solidFill>
+                <a:latin typeface="Arial Black"/>
+              </a:rPr>
+              <a:t>6</a:t>
+            </a:r>
+          </a:p>
+        </p:txBody>
+      </p:sp>
+      <p:sp>
+        <p:nvSpPr>
+          <p:cNvPr id="22" name="TextBox 21"/>
+          <p:cNvSpPr txBox="1"/>
+          <p:nvPr/>
+        </p:nvSpPr>
+        <p:spPr>
+          <a:xfrm>
+            <a:off x="1051560" y="4032503"/>
+            <a:ext cx="2651760" cy="274320"/>
+          </a:xfrm>
+          <a:prstGeom prst="rect">
+            <a:avLst/>
+          </a:prstGeom>
+          <a:noFill/>
+        </p:spPr>
+        <p:txBody>
+          <a:bodyPr wrap="square" lIns="0" rIns="0" tIns="0" bIns="0" anchor="t">
+            <a:spAutoFit/>
+          </a:bodyPr>
+          <a:lstStyle/>
+          <a:p>
+            <a:pPr algn="l"/>
+            <a:r>
+              <a:rPr sz="1050" b="0" i="0">
+                <a:solidFill>
+                  <a:srgbClr val="FFFFFF"/>
+                </a:solidFill>
+                <a:latin typeface="Arial"/>
+              </a:rPr>
+              <a:t>Lucy Dreaming</a:t>
+            </a:r>
+          </a:p>
+        </p:txBody>
+      </p:sp>
+      <p:sp>
+        <p:nvSpPr>
+          <p:cNvPr id="23" name="TextBox 22"/>
+          <p:cNvSpPr txBox="1"/>
+          <p:nvPr/>
+        </p:nvSpPr>
+        <p:spPr>
+          <a:xfrm>
+            <a:off x="3794760" y="4032503"/>
+            <a:ext cx="1234440" cy="274320"/>
+          </a:xfrm>
+          <a:prstGeom prst="rect">
+            <a:avLst/>
+          </a:prstGeom>
+          <a:noFill/>
+        </p:spPr>
+        <p:txBody>
+          <a:bodyPr wrap="square" lIns="0" rIns="0" tIns="0" bIns="0" anchor="t">
+            <a:spAutoFit/>
+          </a:bodyPr>
+          <a:lstStyle/>
+          <a:p>
+            <a:pPr algn="r"/>
+            <a:r>
+              <a:rPr sz="1000" b="0" i="0">
+                <a:solidFill>
+                  <a:srgbClr val="9AA3B2"/>
+                </a:solidFill>
+                <a:latin typeface="Arial"/>
+              </a:rPr>
+              <a:t>118 avis</a:t>
+            </a:r>
+          </a:p>
+        </p:txBody>
+      </p:sp>
+      <p:sp>
+        <p:nvSpPr>
+          <p:cNvPr id="24" name="Rounded Rectangle 23"/>
+          <p:cNvSpPr/>
+          <p:nvPr/>
+        </p:nvSpPr>
+        <p:spPr>
+          <a:xfrm>
+            <a:off x="5440680" y="1645920"/>
+            <a:ext cx="3246120" cy="896112"/>
+          </a:xfrm>
+          <a:prstGeom prst="roundRect">
+            <a:avLst>
+              <a:gd name="adj" fmla="val 10000"/>
+            </a:avLst>
+          </a:prstGeom>
+          <a:solidFill>
+            <a:srgbClr val="14243C"/>
+          </a:solidFill>
+          <a:ln w="15240">
+            <a:solidFill>
+              <a:srgbClr val="29A9E0"/>
+            </a:solidFill>
+          </a:ln>
+          <a:effectLst/>
+        </p:spPr>
+        <p:style>
+          <a:lnRef idx="1">
+            <a:schemeClr val="accent1"/>
+          </a:lnRef>
+          <a:fillRef idx="3">
+            <a:schemeClr val="accent1"/>
+          </a:fillRef>
+          <a:effectRef idx="2">
+            <a:schemeClr val="accent1"/>
+          </a:effectRef>
+          <a:fontRef idx="minor">
+            <a:schemeClr val="lt1"/>
+          </a:fontRef>
+        </p:style>
+        <p:txBody>
+          <a:bodyPr rtlCol="0" anchor="ctr"/>
+          <a:lstStyle/>
+          <a:p>
+            <a:pPr algn="ctr"/>
+          </a:p>
+        </p:txBody>
+      </p:sp>
+      <p:sp>
+        <p:nvSpPr>
+          <p:cNvPr id="25" name="TextBox 24"/>
+          <p:cNvSpPr txBox="1"/>
+          <p:nvPr/>
+        </p:nvSpPr>
+        <p:spPr>
+          <a:xfrm>
+            <a:off x="5577840" y="1805940"/>
+            <a:ext cx="1691639" cy="256032"/>
+          </a:xfrm>
+          <a:prstGeom prst="rect">
+            <a:avLst/>
+          </a:prstGeom>
+          <a:noFill/>
+        </p:spPr>
+        <p:txBody>
+          <a:bodyPr wrap="square" lIns="0" rIns="0" tIns="0" bIns="0" anchor="t">
+            <a:spAutoFit/>
+          </a:bodyPr>
+          <a:lstStyle/>
+          <a:p>
+            <a:pPr algn="l"/>
+            <a:r>
+              <a:rPr sz="1050" b="1" i="0">
+                <a:solidFill>
+                  <a:srgbClr val="29A9E0"/>
+                </a:solidFill>
+                <a:latin typeface="Arial"/>
+              </a:rPr>
+              <a:t>Ratio parfait</a:t>
+            </a:r>
+          </a:p>
+        </p:txBody>
+      </p:sp>
+      <p:sp>
+        <p:nvSpPr>
+          <p:cNvPr id="26" name="TextBox 25"/>
+          <p:cNvSpPr txBox="1"/>
+          <p:nvPr/>
+        </p:nvSpPr>
+        <p:spPr>
+          <a:xfrm>
+            <a:off x="5577840" y="2061972"/>
+            <a:ext cx="1691639" cy="237744"/>
+          </a:xfrm>
+          <a:prstGeom prst="rect">
+            <a:avLst/>
+          </a:prstGeom>
+          <a:noFill/>
+        </p:spPr>
+        <p:txBody>
+          <a:bodyPr wrap="square" lIns="0" rIns="0" tIns="0" bIns="0" anchor="t">
+            <a:spAutoFit/>
+          </a:bodyPr>
+          <a:lstStyle/>
+          <a:p>
+            <a:pPr algn="l"/>
+            <a:r>
+              <a:rPr sz="900" b="0" i="0">
+                <a:solidFill>
+                  <a:srgbClr val="9AA3B2"/>
+                </a:solidFill>
+                <a:latin typeface="Arial"/>
+              </a:rPr>
+              <a:t>6 jeux affichent 100 %</a:t>
+            </a:r>
+          </a:p>
+        </p:txBody>
+      </p:sp>
+      <p:sp>
+        <p:nvSpPr>
+          <p:cNvPr id="27" name="TextBox 26"/>
+          <p:cNvSpPr txBox="1"/>
+          <p:nvPr/>
+        </p:nvSpPr>
+        <p:spPr>
+          <a:xfrm>
+            <a:off x="7132320" y="1842516"/>
+            <a:ext cx="1417320" cy="411480"/>
+          </a:xfrm>
+          <a:prstGeom prst="rect">
+            <a:avLst/>
+          </a:prstGeom>
+          <a:noFill/>
+        </p:spPr>
+        <p:txBody>
+          <a:bodyPr wrap="square" lIns="0" rIns="0" tIns="0" bIns="0" anchor="t">
+            <a:spAutoFit/>
+          </a:bodyPr>
+          <a:lstStyle/>
+          <a:p>
+            <a:pPr algn="r"/>
+            <a:r>
+              <a:rPr sz="1700" b="1" i="0">
+                <a:solidFill>
+                  <a:srgbClr val="29A9E0"/>
+                </a:solidFill>
+                <a:latin typeface="Arial Black"/>
+              </a:rPr>
+              <a:t>100%</a:t>
+            </a:r>
+          </a:p>
+        </p:txBody>
+      </p:sp>
+      <p:sp>
+        <p:nvSpPr>
+          <p:cNvPr id="28" name="Rounded Rectangle 27"/>
+          <p:cNvSpPr/>
+          <p:nvPr/>
+        </p:nvSpPr>
+        <p:spPr>
+          <a:xfrm>
+            <a:off x="5440680" y="2633472"/>
+            <a:ext cx="3246120" cy="896112"/>
+          </a:xfrm>
+          <a:prstGeom prst="roundRect">
+            <a:avLst>
+              <a:gd name="adj" fmla="val 10000"/>
+            </a:avLst>
+          </a:prstGeom>
+          <a:solidFill>
+            <a:srgbClr val="14243C"/>
+          </a:solidFill>
+          <a:ln w="15240">
+            <a:solidFill>
+              <a:srgbClr val="F2C719"/>
+            </a:solidFill>
+          </a:ln>
+          <a:effectLst/>
+        </p:spPr>
+        <p:style>
+          <a:lnRef idx="1">
+            <a:schemeClr val="accent1"/>
+          </a:lnRef>
+          <a:fillRef idx="3">
+            <a:schemeClr val="accent1"/>
+          </a:fillRef>
+          <a:effectRef idx="2">
+            <a:schemeClr val="accent1"/>
+          </a:effectRef>
+          <a:fontRef idx="minor">
+            <a:schemeClr val="lt1"/>
+          </a:fontRef>
+        </p:style>
+        <p:txBody>
+          <a:bodyPr rtlCol="0" anchor="ctr"/>
+          <a:lstStyle/>
+          <a:p>
+            <a:pPr algn="ctr"/>
+          </a:p>
+        </p:txBody>
+      </p:sp>
+      <p:sp>
+        <p:nvSpPr>
+          <p:cNvPr id="29" name="TextBox 28"/>
+          <p:cNvSpPr txBox="1"/>
+          <p:nvPr/>
+        </p:nvSpPr>
+        <p:spPr>
+          <a:xfrm>
+            <a:off x="5577840" y="2793491"/>
+            <a:ext cx="1691639" cy="256032"/>
+          </a:xfrm>
+          <a:prstGeom prst="rect">
+            <a:avLst/>
+          </a:prstGeom>
+          <a:noFill/>
+        </p:spPr>
+        <p:txBody>
+          <a:bodyPr wrap="square" lIns="0" rIns="0" tIns="0" bIns="0" anchor="t">
+            <a:spAutoFit/>
+          </a:bodyPr>
+          <a:lstStyle/>
+          <a:p>
+            <a:pPr algn="l"/>
+            <a:r>
+              <a:rPr sz="1050" b="1" i="0">
+                <a:solidFill>
+                  <a:srgbClr val="F2C719"/>
+                </a:solidFill>
+                <a:latin typeface="Arial"/>
+              </a:rPr>
+              <a:t>Seuil retenu</a:t>
+            </a:r>
+          </a:p>
+        </p:txBody>
+      </p:sp>
+      <p:sp>
+        <p:nvSpPr>
+          <p:cNvPr id="30" name="TextBox 29"/>
+          <p:cNvSpPr txBox="1"/>
+          <p:nvPr/>
+        </p:nvSpPr>
+        <p:spPr>
+          <a:xfrm>
+            <a:off x="5577840" y="3049524"/>
+            <a:ext cx="1691639" cy="237744"/>
+          </a:xfrm>
+          <a:prstGeom prst="rect">
+            <a:avLst/>
+          </a:prstGeom>
+          <a:noFill/>
+        </p:spPr>
+        <p:txBody>
+          <a:bodyPr wrap="square" lIns="0" rIns="0" tIns="0" bIns="0" anchor="t">
+            <a:spAutoFit/>
+          </a:bodyPr>
+          <a:lstStyle/>
+          <a:p>
+            <a:pPr algn="l"/>
+            <a:r>
+              <a:rPr sz="900" b="0" i="0">
+                <a:solidFill>
+                  <a:srgbClr val="9AA3B2"/>
+                </a:solidFill>
+                <a:latin typeface="Arial"/>
+              </a:rPr>
+              <a:t>Avis minimum par jeu</a:t>
+            </a:r>
+          </a:p>
+        </p:txBody>
+      </p:sp>
+      <p:sp>
+        <p:nvSpPr>
+          <p:cNvPr id="31" name="TextBox 30"/>
+          <p:cNvSpPr txBox="1"/>
+          <p:nvPr/>
+        </p:nvSpPr>
+        <p:spPr>
+          <a:xfrm>
+            <a:off x="7132320" y="2830068"/>
+            <a:ext cx="1417320" cy="411480"/>
+          </a:xfrm>
+          <a:prstGeom prst="rect">
+            <a:avLst/>
+          </a:prstGeom>
+          <a:noFill/>
+        </p:spPr>
+        <p:txBody>
+          <a:bodyPr wrap="square" lIns="0" rIns="0" tIns="0" bIns="0" anchor="t">
+            <a:spAutoFit/>
+          </a:bodyPr>
+          <a:lstStyle/>
+          <a:p>
+            <a:pPr algn="r"/>
+            <a:r>
+              <a:rPr sz="1700" b="1" i="0">
+                <a:solidFill>
+                  <a:srgbClr val="F2C719"/>
+                </a:solidFill>
+                <a:latin typeface="Arial Black"/>
+              </a:rPr>
+              <a:t>100</a:t>
+            </a:r>
+          </a:p>
+        </p:txBody>
+      </p:sp>
+      <p:sp>
+        <p:nvSpPr>
+          <p:cNvPr id="32" name="Rounded Rectangle 31"/>
+          <p:cNvSpPr/>
+          <p:nvPr/>
+        </p:nvSpPr>
+        <p:spPr>
+          <a:xfrm>
+            <a:off x="5440680" y="3621024"/>
+            <a:ext cx="3246120" cy="905256"/>
+          </a:xfrm>
+          <a:prstGeom prst="roundRect">
+            <a:avLst>
+              <a:gd name="adj" fmla="val 10000"/>
+            </a:avLst>
+          </a:prstGeom>
+          <a:solidFill>
+            <a:srgbClr val="14243C"/>
+          </a:solidFill>
+          <a:ln w="15240">
+            <a:solidFill>
+              <a:srgbClr val="EF3E5C"/>
+            </a:solidFill>
+          </a:ln>
+          <a:effectLst/>
+        </p:spPr>
+        <p:style>
+          <a:lnRef idx="1">
+            <a:schemeClr val="accent1"/>
+          </a:lnRef>
+          <a:fillRef idx="3">
+            <a:schemeClr val="accent1"/>
+          </a:fillRef>
+          <a:effectRef idx="2">
+            <a:schemeClr val="accent1"/>
+          </a:effectRef>
+          <a:fontRef idx="minor">
+            <a:schemeClr val="lt1"/>
+          </a:fontRef>
+        </p:style>
+        <p:txBody>
+          <a:bodyPr rtlCol="0" anchor="ctr"/>
+          <a:lstStyle/>
+          <a:p>
+            <a:pPr algn="ctr"/>
+          </a:p>
+        </p:txBody>
+      </p:sp>
+      <p:sp>
+        <p:nvSpPr>
+          <p:cNvPr id="33" name="TextBox 32"/>
+          <p:cNvSpPr txBox="1"/>
+          <p:nvPr/>
+        </p:nvSpPr>
+        <p:spPr>
+          <a:xfrm>
+            <a:off x="5586984" y="3730752"/>
+            <a:ext cx="2953512" cy="256032"/>
+          </a:xfrm>
+          <a:prstGeom prst="rect">
+            <a:avLst/>
+          </a:prstGeom>
+          <a:noFill/>
+        </p:spPr>
+        <p:txBody>
+          <a:bodyPr wrap="square" lIns="0" rIns="0" tIns="0" bIns="0" anchor="t">
+            <a:spAutoFit/>
+          </a:bodyPr>
+          <a:lstStyle/>
+          <a:p>
+            <a:pPr algn="l"/>
+            <a:r>
+              <a:rPr sz="1050" b="1" i="0">
+                <a:solidFill>
+                  <a:srgbClr val="EF3E5C"/>
+                </a:solidFill>
+                <a:latin typeface="Arial"/>
+              </a:rPr>
+              <a:t>À retenir</a:t>
+            </a:r>
+          </a:p>
+        </p:txBody>
+      </p:sp>
+      <p:sp>
+        <p:nvSpPr>
+          <p:cNvPr id="34" name="TextBox 33"/>
+          <p:cNvSpPr txBox="1"/>
+          <p:nvPr/>
+        </p:nvSpPr>
+        <p:spPr>
+          <a:xfrm>
+            <a:off x="5586984" y="4005072"/>
+            <a:ext cx="2953512" cy="448056"/>
+          </a:xfrm>
+          <a:prstGeom prst="rect">
+            <a:avLst/>
+          </a:prstGeom>
+          <a:noFill/>
+        </p:spPr>
+        <p:txBody>
+          <a:bodyPr wrap="square" lIns="0" rIns="0" tIns="0" bIns="0" anchor="t">
+            <a:spAutoFit/>
+          </a:bodyPr>
+          <a:lstStyle/>
+          <a:p>
+            <a:pPr algn="l"/>
+            <a:r>
+              <a:rPr sz="950" b="0" i="0">
+                <a:solidFill>
+                  <a:srgbClr val="D7DCE6"/>
+                </a:solidFill>
+                <a:latin typeface="Arial"/>
+              </a:rPr>
+              <a:t>Un excellent ratio traduit un petit public conquis, pas un succès commercial.</a:t>
+            </a:r>
+          </a:p>
+        </p:txBody>
+      </p:sp>
+      <p:sp>
+        <p:nvSpPr>
+          <p:cNvPr id="35" name="TextBox 34"/>
+          <p:cNvSpPr txBox="1"/>
+          <p:nvPr/>
+        </p:nvSpPr>
+        <p:spPr>
+          <a:xfrm>
+            <a:off x="457200" y="4736592"/>
+            <a:ext cx="8229600" cy="320040"/>
+          </a:xfrm>
+          <a:prstGeom prst="rect">
+            <a:avLst/>
+          </a:prstGeom>
+          <a:noFill/>
+        </p:spPr>
+        <p:txBody>
+          <a:bodyPr wrap="square" lIns="0" rIns="0" tIns="0" bIns="0" anchor="t">
+            <a:spAutoFit/>
+          </a:bodyPr>
+          <a:lstStyle/>
+          <a:p>
+            <a:pPr algn="l"/>
+            <a:r>
+              <a:rPr sz="1000" b="0" i="1">
+                <a:solidFill>
+                  <a:srgbClr val="EF3E5C"/>
+                </a:solidFill>
+                <a:latin typeface="Arial"/>
+              </a:rPr>
+              <a:t>Insight : les mieux notés sont de petits jeux au public restreint mais conquis. Un excellent ratio d'avis ne signale pas un succès commercial.</a:t>
+            </a:r>
+          </a:p>
+        </p:txBody>
+      </p:sp>
+    </p:spTree>
+  </p:cSld>
+  <p:clrMapOvr>
+    <a:masterClrMapping/>
+  </p:clrMapOvr>
+</p:sld>
+</file>
+
+<file path=ppt/slides/slide11.xml><?xml version="1.0" encoding="utf-8"?>
+<p:sld xmlns:a="http://schemas.openxmlformats.org/drawingml/2006/main" xmlns:p="http://schemas.openxmlformats.org/presentationml/2006/main" xmlns:r="http://schemas.openxmlformats.org/officeDocument/2006/relationships">
+  <p:cSld>
+    <p:spTree>
+      <p:nvGrpSpPr>
+        <p:cNvPr id="1" name=""/>
+        <p:cNvGrpSpPr/>
+        <p:nvPr/>
+      </p:nvGrpSpPr>
+      <p:grpSpPr/>
+      <p:sp>
+        <p:nvSpPr>
+          <p:cNvPr id="2" name="TextBox 1"/>
+          <p:cNvSpPr txBox="1"/>
+          <p:nvPr/>
+        </p:nvSpPr>
+        <p:spPr>
+          <a:xfrm>
+            <a:off x="457200" y="256032"/>
+            <a:ext cx="7772400" cy="274320"/>
+          </a:xfrm>
+          <a:prstGeom prst="rect">
+            <a:avLst/>
+          </a:prstGeom>
+          <a:noFill/>
+        </p:spPr>
+        <p:txBody>
+          <a:bodyPr wrap="square" lIns="0" rIns="0" tIns="0" bIns="0" anchor="t">
+            <a:spAutoFit/>
+          </a:bodyPr>
+          <a:lstStyle/>
+          <a:p>
+            <a:pPr algn="l"/>
+            <a:r>
+              <a:rPr sz="1100" b="1" i="0">
+                <a:solidFill>
+                  <a:srgbClr val="EF3E5C"/>
+                </a:solidFill>
+                <a:latin typeface="Arial"/>
+              </a:rPr>
+              <a:t>A N A L Y S E   M A C R O   -   4 / 5</a:t>
+            </a:r>
+          </a:p>
+        </p:txBody>
+      </p:sp>
+      <p:sp>
+        <p:nvSpPr>
+          <p:cNvPr id="3" name="TextBox 2"/>
+          <p:cNvSpPr txBox="1"/>
+          <p:nvPr/>
+        </p:nvSpPr>
+        <p:spPr>
+          <a:xfrm>
+            <a:off x="420624" y="502920"/>
+            <a:ext cx="8229600" cy="777240"/>
+          </a:xfrm>
+          <a:prstGeom prst="rect">
+            <a:avLst/>
+          </a:prstGeom>
+          <a:noFill/>
+        </p:spPr>
+        <p:txBody>
+          <a:bodyPr wrap="square" lIns="0" rIns="0" tIns="0" bIns="0" anchor="t">
+            <a:spAutoFit/>
+          </a:bodyPr>
+          <a:lstStyle/>
+          <a:p>
+            <a:pPr algn="l"/>
+            <a:r>
+              <a:rPr sz="3400" b="1" i="0">
+                <a:solidFill>
+                  <a:srgbClr val="FFFFFF"/>
+                </a:solidFill>
+                <a:latin typeface="Arial Black"/>
+              </a:rPr>
+              <a:t>La distribution des prix</a:t>
+            </a:r>
+          </a:p>
+        </p:txBody>
+      </p:sp>
+      <p:sp>
+        <p:nvSpPr>
+          <p:cNvPr id="4" name="TextBox 3"/>
+          <p:cNvSpPr txBox="1"/>
+          <p:nvPr/>
+        </p:nvSpPr>
+        <p:spPr>
+          <a:xfrm>
+            <a:off x="457200" y="1325880"/>
+            <a:ext cx="4572000" cy="274320"/>
+          </a:xfrm>
+          <a:prstGeom prst="rect">
+            <a:avLst/>
+          </a:prstGeom>
+          <a:noFill/>
+        </p:spPr>
+        <p:txBody>
+          <a:bodyPr wrap="square" lIns="0" rIns="0" tIns="0" bIns="0" anchor="t">
+            <a:spAutoFit/>
+          </a:bodyPr>
+          <a:lstStyle/>
+          <a:p>
+            <a:pPr algn="l"/>
+            <a:r>
+              <a:rPr sz="1300" b="1" i="0">
+                <a:solidFill>
+                  <a:srgbClr val="29A9E0"/>
+                </a:solidFill>
+                <a:latin typeface="Arial"/>
+              </a:rPr>
+              <a:t>Jeux payants par tranche de prix</a:t>
+            </a:r>
+          </a:p>
+        </p:txBody>
+      </p:sp>
+      <p:sp>
+        <p:nvSpPr>
+          <p:cNvPr id="5" name="Rounded Rectangle 4"/>
+          <p:cNvSpPr/>
+          <p:nvPr/>
+        </p:nvSpPr>
+        <p:spPr>
+          <a:xfrm>
+            <a:off x="457200" y="1645920"/>
+            <a:ext cx="4754880" cy="2880360"/>
+          </a:xfrm>
+          <a:prstGeom prst="roundRect">
+            <a:avLst>
+              <a:gd name="adj" fmla="val 5000"/>
+            </a:avLst>
+          </a:prstGeom>
+          <a:solidFill>
+            <a:srgbClr val="16263F"/>
+          </a:solidFill>
+          <a:ln w="12700">
+            <a:solidFill>
+              <a:srgbClr val="24344F"/>
+            </a:solidFill>
+          </a:ln>
+          <a:effectLst/>
+        </p:spPr>
+        <p:style>
+          <a:lnRef idx="1">
+            <a:schemeClr val="accent1"/>
+          </a:lnRef>
+          <a:fillRef idx="3">
+            <a:schemeClr val="accent1"/>
+          </a:fillRef>
+          <a:effectRef idx="2">
+            <a:schemeClr val="accent1"/>
+          </a:effectRef>
+          <a:fontRef idx="minor">
+            <a:schemeClr val="lt1"/>
+          </a:fontRef>
+        </p:style>
+        <p:txBody>
+          <a:bodyPr rtlCol="0" anchor="ctr"/>
+          <a:lstStyle/>
+          <a:p>
+            <a:pPr algn="ctr"/>
+          </a:p>
+        </p:txBody>
+      </p:sp>
+      <p:sp>
+        <p:nvSpPr>
+          <p:cNvPr id="6" name="TextBox 5"/>
+          <p:cNvSpPr txBox="1"/>
+          <p:nvPr/>
+        </p:nvSpPr>
+        <p:spPr>
+          <a:xfrm>
+            <a:off x="566928" y="1947672"/>
+            <a:ext cx="1234440" cy="274320"/>
+          </a:xfrm>
+          <a:prstGeom prst="rect">
+            <a:avLst/>
+          </a:prstGeom>
+          <a:noFill/>
+        </p:spPr>
+        <p:txBody>
+          <a:bodyPr wrap="square" lIns="0" rIns="0" tIns="0" bIns="0" anchor="t">
+            <a:spAutoFit/>
+          </a:bodyPr>
+          <a:lstStyle/>
+          <a:p>
+            <a:pPr algn="l"/>
+            <a:r>
+              <a:rPr sz="1000" b="0" i="0">
+                <a:solidFill>
+                  <a:srgbClr val="FFFFFF"/>
+                </a:solidFill>
+                <a:latin typeface="Arial"/>
+              </a:rPr>
+              <a:t>Moins de 5 €</a:t>
+            </a:r>
+          </a:p>
+        </p:txBody>
+      </p:sp>
+      <p:sp>
+        <p:nvSpPr>
+          <p:cNvPr id="7" name="Rectangle 6"/>
+          <p:cNvSpPr/>
+          <p:nvPr/>
+        </p:nvSpPr>
+        <p:spPr>
+          <a:xfrm>
+            <a:off x="1874519" y="1984248"/>
+            <a:ext cx="2240280" cy="201168"/>
+          </a:xfrm>
+          <a:prstGeom prst="rect">
+            <a:avLst/>
+          </a:prstGeom>
+          <a:solidFill>
+            <a:srgbClr val="EF3E5C"/>
+          </a:solidFill>
+          <a:ln>
+            <a:noFill/>
+          </a:ln>
+          <a:effectLst/>
+        </p:spPr>
+        <p:style>
+          <a:lnRef idx="1">
+            <a:schemeClr val="accent1"/>
+          </a:lnRef>
+          <a:fillRef idx="3">
+            <a:schemeClr val="accent1"/>
+          </a:fillRef>
+          <a:effectRef idx="2">
+            <a:schemeClr val="accent1"/>
+          </a:effectRef>
+          <a:fontRef idx="minor">
+            <a:schemeClr val="lt1"/>
+          </a:fontRef>
+        </p:style>
+        <p:txBody>
+          <a:bodyPr rtlCol="0" anchor="ctr"/>
+          <a:lstStyle/>
+          <a:p>
+            <a:pPr algn="ctr"/>
+          </a:p>
+        </p:txBody>
+      </p:sp>
+      <p:sp>
+        <p:nvSpPr>
+          <p:cNvPr id="8" name="TextBox 7"/>
+          <p:cNvSpPr txBox="1"/>
+          <p:nvPr/>
+        </p:nvSpPr>
+        <p:spPr>
+          <a:xfrm>
+            <a:off x="4187952" y="1947672"/>
+            <a:ext cx="868680" cy="274320"/>
+          </a:xfrm>
+          <a:prstGeom prst="rect">
+            <a:avLst/>
+          </a:prstGeom>
+          <a:noFill/>
+        </p:spPr>
+        <p:txBody>
+          <a:bodyPr wrap="square" lIns="0" rIns="0" tIns="0" bIns="0" anchor="t">
+            <a:spAutoFit/>
+          </a:bodyPr>
+          <a:lstStyle/>
+          <a:p>
+            <a:pPr algn="l"/>
+            <a:r>
+              <a:rPr sz="1000" b="1" i="0">
+                <a:solidFill>
+                  <a:srgbClr val="D7DCE6"/>
+                </a:solidFill>
+                <a:latin typeface="Arial"/>
+              </a:rPr>
+              <a:t>48,2 %</a:t>
+            </a:r>
+          </a:p>
+        </p:txBody>
+      </p:sp>
+      <p:sp>
+        <p:nvSpPr>
+          <p:cNvPr id="9" name="TextBox 8"/>
+          <p:cNvSpPr txBox="1"/>
+          <p:nvPr/>
+        </p:nvSpPr>
+        <p:spPr>
+          <a:xfrm>
+            <a:off x="566928" y="2459736"/>
+            <a:ext cx="1234440" cy="274320"/>
+          </a:xfrm>
+          <a:prstGeom prst="rect">
+            <a:avLst/>
+          </a:prstGeom>
+          <a:noFill/>
+        </p:spPr>
+        <p:txBody>
+          <a:bodyPr wrap="square" lIns="0" rIns="0" tIns="0" bIns="0" anchor="t">
+            <a:spAutoFit/>
+          </a:bodyPr>
+          <a:lstStyle/>
+          <a:p>
+            <a:pPr algn="l"/>
+            <a:r>
+              <a:rPr sz="1000" b="0" i="0">
+                <a:solidFill>
+                  <a:srgbClr val="FFFFFF"/>
+                </a:solidFill>
+                <a:latin typeface="Arial"/>
+              </a:rPr>
+              <a:t>5 à 10 €</a:t>
+            </a:r>
+          </a:p>
+        </p:txBody>
+      </p:sp>
+      <p:sp>
+        <p:nvSpPr>
+          <p:cNvPr id="10" name="Rectangle 9"/>
+          <p:cNvSpPr/>
+          <p:nvPr/>
+        </p:nvSpPr>
+        <p:spPr>
+          <a:xfrm>
+            <a:off x="1874519" y="2496312"/>
+            <a:ext cx="1134083" cy="201168"/>
+          </a:xfrm>
+          <a:prstGeom prst="rect">
+            <a:avLst/>
+          </a:prstGeom>
+          <a:solidFill>
+            <a:srgbClr val="29A9E0"/>
+          </a:solidFill>
+          <a:ln>
+            <a:noFill/>
+          </a:ln>
+          <a:effectLst/>
+        </p:spPr>
+        <p:style>
+          <a:lnRef idx="1">
+            <a:schemeClr val="accent1"/>
+          </a:lnRef>
+          <a:fillRef idx="3">
+            <a:schemeClr val="accent1"/>
+          </a:fillRef>
+          <a:effectRef idx="2">
+            <a:schemeClr val="accent1"/>
+          </a:effectRef>
+          <a:fontRef idx="minor">
+            <a:schemeClr val="lt1"/>
+          </a:fontRef>
+        </p:style>
+        <p:txBody>
+          <a:bodyPr rtlCol="0" anchor="ctr"/>
+          <a:lstStyle/>
+          <a:p>
+            <a:pPr algn="ctr"/>
+          </a:p>
+        </p:txBody>
+      </p:sp>
+      <p:sp>
+        <p:nvSpPr>
+          <p:cNvPr id="11" name="TextBox 10"/>
+          <p:cNvSpPr txBox="1"/>
+          <p:nvPr/>
+        </p:nvSpPr>
+        <p:spPr>
+          <a:xfrm>
+            <a:off x="3081755" y="2459736"/>
+            <a:ext cx="868680" cy="274320"/>
+          </a:xfrm>
+          <a:prstGeom prst="rect">
+            <a:avLst/>
+          </a:prstGeom>
+          <a:noFill/>
+        </p:spPr>
+        <p:txBody>
+          <a:bodyPr wrap="square" lIns="0" rIns="0" tIns="0" bIns="0" anchor="t">
+            <a:spAutoFit/>
+          </a:bodyPr>
+          <a:lstStyle/>
+          <a:p>
+            <a:pPr algn="l"/>
+            <a:r>
+              <a:rPr sz="1000" b="1" i="0">
+                <a:solidFill>
+                  <a:srgbClr val="D7DCE6"/>
+                </a:solidFill>
+                <a:latin typeface="Arial"/>
+              </a:rPr>
+              <a:t>24,4 %</a:t>
+            </a:r>
+          </a:p>
+        </p:txBody>
+      </p:sp>
+      <p:sp>
+        <p:nvSpPr>
+          <p:cNvPr id="12" name="TextBox 11"/>
+          <p:cNvSpPr txBox="1"/>
+          <p:nvPr/>
+        </p:nvSpPr>
+        <p:spPr>
+          <a:xfrm>
+            <a:off x="566928" y="2971800"/>
+            <a:ext cx="1234440" cy="274320"/>
+          </a:xfrm>
+          <a:prstGeom prst="rect">
+            <a:avLst/>
+          </a:prstGeom>
+          <a:noFill/>
+        </p:spPr>
+        <p:txBody>
+          <a:bodyPr wrap="square" lIns="0" rIns="0" tIns="0" bIns="0" anchor="t">
+            <a:spAutoFit/>
+          </a:bodyPr>
+          <a:lstStyle/>
+          <a:p>
+            <a:pPr algn="l"/>
+            <a:r>
+              <a:rPr sz="1000" b="0" i="0">
+                <a:solidFill>
+                  <a:srgbClr val="FFFFFF"/>
+                </a:solidFill>
+                <a:latin typeface="Arial"/>
+              </a:rPr>
+              <a:t>10 à 20 €</a:t>
+            </a:r>
+          </a:p>
+        </p:txBody>
+      </p:sp>
+      <p:sp>
+        <p:nvSpPr>
+          <p:cNvPr id="13" name="Rectangle 12"/>
+          <p:cNvSpPr/>
+          <p:nvPr/>
+        </p:nvSpPr>
+        <p:spPr>
+          <a:xfrm>
+            <a:off x="1874519" y="3008376"/>
+            <a:ext cx="966759" cy="201168"/>
+          </a:xfrm>
+          <a:prstGeom prst="rect">
+            <a:avLst/>
+          </a:prstGeom>
+          <a:solidFill>
+            <a:srgbClr val="29A9E0"/>
+          </a:solidFill>
+          <a:ln>
+            <a:noFill/>
+          </a:ln>
+          <a:effectLst/>
+        </p:spPr>
+        <p:style>
+          <a:lnRef idx="1">
+            <a:schemeClr val="accent1"/>
+          </a:lnRef>
+          <a:fillRef idx="3">
+            <a:schemeClr val="accent1"/>
+          </a:fillRef>
+          <a:effectRef idx="2">
+            <a:schemeClr val="accent1"/>
+          </a:effectRef>
+          <a:fontRef idx="minor">
+            <a:schemeClr val="lt1"/>
+          </a:fontRef>
+        </p:style>
+        <p:txBody>
+          <a:bodyPr rtlCol="0" anchor="ctr"/>
+          <a:lstStyle/>
+          <a:p>
+            <a:pPr algn="ctr"/>
+          </a:p>
+        </p:txBody>
+      </p:sp>
+      <p:sp>
+        <p:nvSpPr>
+          <p:cNvPr id="14" name="TextBox 13"/>
+          <p:cNvSpPr txBox="1"/>
+          <p:nvPr/>
+        </p:nvSpPr>
+        <p:spPr>
+          <a:xfrm>
+            <a:off x="2914431" y="2971800"/>
+            <a:ext cx="868680" cy="274320"/>
+          </a:xfrm>
+          <a:prstGeom prst="rect">
+            <a:avLst/>
+          </a:prstGeom>
+          <a:noFill/>
+        </p:spPr>
+        <p:txBody>
+          <a:bodyPr wrap="square" lIns="0" rIns="0" tIns="0" bIns="0" anchor="t">
+            <a:spAutoFit/>
+          </a:bodyPr>
+          <a:lstStyle/>
+          <a:p>
+            <a:pPr algn="l"/>
+            <a:r>
+              <a:rPr sz="1000" b="1" i="0">
+                <a:solidFill>
+                  <a:srgbClr val="D7DCE6"/>
+                </a:solidFill>
+                <a:latin typeface="Arial"/>
+              </a:rPr>
+              <a:t>20,8 %</a:t>
+            </a:r>
+          </a:p>
+        </p:txBody>
+      </p:sp>
+      <p:sp>
+        <p:nvSpPr>
+          <p:cNvPr id="15" name="TextBox 14"/>
+          <p:cNvSpPr txBox="1"/>
+          <p:nvPr/>
+        </p:nvSpPr>
+        <p:spPr>
+          <a:xfrm>
+            <a:off x="566928" y="3483864"/>
+            <a:ext cx="1234440" cy="274320"/>
+          </a:xfrm>
+          <a:prstGeom prst="rect">
+            <a:avLst/>
+          </a:prstGeom>
+          <a:noFill/>
+        </p:spPr>
+        <p:txBody>
+          <a:bodyPr wrap="square" lIns="0" rIns="0" tIns="0" bIns="0" anchor="t">
+            <a:spAutoFit/>
+          </a:bodyPr>
+          <a:lstStyle/>
+          <a:p>
+            <a:pPr algn="l"/>
+            <a:r>
+              <a:rPr sz="1000" b="0" i="0">
+                <a:solidFill>
+                  <a:srgbClr val="FFFFFF"/>
+                </a:solidFill>
+                <a:latin typeface="Arial"/>
+              </a:rPr>
+              <a:t>20 à 50 €</a:t>
+            </a:r>
+          </a:p>
+        </p:txBody>
+      </p:sp>
+      <p:sp>
+        <p:nvSpPr>
+          <p:cNvPr id="16" name="Rectangle 15"/>
+          <p:cNvSpPr/>
+          <p:nvPr/>
+        </p:nvSpPr>
+        <p:spPr>
+          <a:xfrm>
+            <a:off x="1874519" y="3520440"/>
+            <a:ext cx="264929" cy="201168"/>
+          </a:xfrm>
+          <a:prstGeom prst="rect">
+            <a:avLst/>
+          </a:prstGeom>
+          <a:solidFill>
+            <a:srgbClr val="29A9E0"/>
+          </a:solidFill>
+          <a:ln>
+            <a:noFill/>
+          </a:ln>
+          <a:effectLst/>
+        </p:spPr>
+        <p:style>
+          <a:lnRef idx="1">
+            <a:schemeClr val="accent1"/>
+          </a:lnRef>
+          <a:fillRef idx="3">
+            <a:schemeClr val="accent1"/>
+          </a:fillRef>
+          <a:effectRef idx="2">
+            <a:schemeClr val="accent1"/>
+          </a:effectRef>
+          <a:fontRef idx="minor">
+            <a:schemeClr val="lt1"/>
+          </a:fontRef>
+        </p:style>
+        <p:txBody>
+          <a:bodyPr rtlCol="0" anchor="ctr"/>
+          <a:lstStyle/>
+          <a:p>
+            <a:pPr algn="ctr"/>
+          </a:p>
+        </p:txBody>
+      </p:sp>
+      <p:sp>
+        <p:nvSpPr>
+          <p:cNvPr id="17" name="TextBox 16"/>
+          <p:cNvSpPr txBox="1"/>
+          <p:nvPr/>
+        </p:nvSpPr>
+        <p:spPr>
+          <a:xfrm>
+            <a:off x="2212601" y="3483864"/>
+            <a:ext cx="868680" cy="274320"/>
+          </a:xfrm>
+          <a:prstGeom prst="rect">
+            <a:avLst/>
+          </a:prstGeom>
+          <a:noFill/>
+        </p:spPr>
+        <p:txBody>
+          <a:bodyPr wrap="square" lIns="0" rIns="0" tIns="0" bIns="0" anchor="t">
+            <a:spAutoFit/>
+          </a:bodyPr>
+          <a:lstStyle/>
+          <a:p>
+            <a:pPr algn="l"/>
+            <a:r>
+              <a:rPr sz="1000" b="1" i="0">
+                <a:solidFill>
+                  <a:srgbClr val="D7DCE6"/>
+                </a:solidFill>
+                <a:latin typeface="Arial"/>
+              </a:rPr>
+              <a:t>5,7 %</a:t>
+            </a:r>
+          </a:p>
+        </p:txBody>
+      </p:sp>
+      <p:sp>
+        <p:nvSpPr>
+          <p:cNvPr id="18" name="TextBox 17"/>
+          <p:cNvSpPr txBox="1"/>
+          <p:nvPr/>
+        </p:nvSpPr>
+        <p:spPr>
+          <a:xfrm>
+            <a:off x="566928" y="3995928"/>
+            <a:ext cx="1234440" cy="274320"/>
+          </a:xfrm>
+          <a:prstGeom prst="rect">
+            <a:avLst/>
+          </a:prstGeom>
+          <a:noFill/>
+        </p:spPr>
+        <p:txBody>
+          <a:bodyPr wrap="square" lIns="0" rIns="0" tIns="0" bIns="0" anchor="t">
+            <a:spAutoFit/>
+          </a:bodyPr>
+          <a:lstStyle/>
+          <a:p>
+            <a:pPr algn="l"/>
+            <a:r>
+              <a:rPr sz="1000" b="0" i="0">
+                <a:solidFill>
+                  <a:srgbClr val="FFFFFF"/>
+                </a:solidFill>
+                <a:latin typeface="Arial"/>
+              </a:rPr>
+              <a:t>50 € et plus</a:t>
+            </a:r>
+          </a:p>
+        </p:txBody>
+      </p:sp>
+      <p:sp>
+        <p:nvSpPr>
+          <p:cNvPr id="19" name="Rectangle 18"/>
+          <p:cNvSpPr/>
+          <p:nvPr/>
+        </p:nvSpPr>
+        <p:spPr>
+          <a:xfrm>
+            <a:off x="1874519" y="4032504"/>
+            <a:ext cx="41830" cy="201168"/>
+          </a:xfrm>
+          <a:prstGeom prst="rect">
+            <a:avLst/>
+          </a:prstGeom>
+          <a:solidFill>
+            <a:srgbClr val="29A9E0"/>
+          </a:solidFill>
+          <a:ln>
+            <a:noFill/>
+          </a:ln>
+          <a:effectLst/>
+        </p:spPr>
+        <p:style>
+          <a:lnRef idx="1">
+            <a:schemeClr val="accent1"/>
+          </a:lnRef>
+          <a:fillRef idx="3">
+            <a:schemeClr val="accent1"/>
+          </a:fillRef>
+          <a:effectRef idx="2">
+            <a:schemeClr val="accent1"/>
+          </a:effectRef>
+          <a:fontRef idx="minor">
+            <a:schemeClr val="lt1"/>
+          </a:fontRef>
+        </p:style>
+        <p:txBody>
+          <a:bodyPr rtlCol="0" anchor="ctr"/>
+          <a:lstStyle/>
+          <a:p>
+            <a:pPr algn="ctr"/>
+          </a:p>
+        </p:txBody>
+      </p:sp>
+      <p:sp>
+        <p:nvSpPr>
+          <p:cNvPr id="20" name="TextBox 19"/>
+          <p:cNvSpPr txBox="1"/>
+          <p:nvPr/>
+        </p:nvSpPr>
+        <p:spPr>
+          <a:xfrm>
+            <a:off x="1989502" y="3995928"/>
+            <a:ext cx="868680" cy="274320"/>
+          </a:xfrm>
+          <a:prstGeom prst="rect">
+            <a:avLst/>
+          </a:prstGeom>
+          <a:noFill/>
+        </p:spPr>
+        <p:txBody>
+          <a:bodyPr wrap="square" lIns="0" rIns="0" tIns="0" bIns="0" anchor="t">
+            <a:spAutoFit/>
+          </a:bodyPr>
+          <a:lstStyle/>
+          <a:p>
+            <a:pPr algn="l"/>
+            <a:r>
+              <a:rPr sz="1000" b="1" i="0">
+                <a:solidFill>
+                  <a:srgbClr val="D7DCE6"/>
+                </a:solidFill>
+                <a:latin typeface="Arial"/>
+              </a:rPr>
+              <a:t>0,9 %</a:t>
+            </a:r>
+          </a:p>
+        </p:txBody>
+      </p:sp>
+      <p:sp>
+        <p:nvSpPr>
+          <p:cNvPr id="21" name="Rounded Rectangle 20"/>
+          <p:cNvSpPr/>
+          <p:nvPr/>
+        </p:nvSpPr>
+        <p:spPr>
+          <a:xfrm>
+            <a:off x="5440680" y="1645920"/>
+            <a:ext cx="3246120" cy="640080"/>
+          </a:xfrm>
+          <a:prstGeom prst="roundRect">
+            <a:avLst>
+              <a:gd name="adj" fmla="val 10000"/>
+            </a:avLst>
+          </a:prstGeom>
+          <a:solidFill>
+            <a:srgbClr val="14243C"/>
+          </a:solidFill>
+          <a:ln w="15240">
+            <a:solidFill>
+              <a:srgbClr val="29A9E0"/>
+            </a:solidFill>
+          </a:ln>
+          <a:effectLst/>
+        </p:spPr>
+        <p:style>
+          <a:lnRef idx="1">
+            <a:schemeClr val="accent1"/>
+          </a:lnRef>
+          <a:fillRef idx="3">
+            <a:schemeClr val="accent1"/>
+          </a:fillRef>
+          <a:effectRef idx="2">
+            <a:schemeClr val="accent1"/>
+          </a:effectRef>
+          <a:fontRef idx="minor">
+            <a:schemeClr val="lt1"/>
+          </a:fontRef>
+        </p:style>
+        <p:txBody>
+          <a:bodyPr rtlCol="0" anchor="ctr"/>
+          <a:lstStyle/>
+          <a:p>
+            <a:pPr algn="ctr"/>
+          </a:p>
+        </p:txBody>
+      </p:sp>
+      <p:sp>
+        <p:nvSpPr>
+          <p:cNvPr id="22" name="TextBox 21"/>
+          <p:cNvSpPr txBox="1"/>
+          <p:nvPr/>
+        </p:nvSpPr>
+        <p:spPr>
+          <a:xfrm>
+            <a:off x="5577840" y="1677924"/>
+            <a:ext cx="1691639" cy="256032"/>
+          </a:xfrm>
+          <a:prstGeom prst="rect">
+            <a:avLst/>
+          </a:prstGeom>
+          <a:noFill/>
+        </p:spPr>
+        <p:txBody>
+          <a:bodyPr wrap="square" lIns="0" rIns="0" tIns="0" bIns="0" anchor="t">
+            <a:spAutoFit/>
+          </a:bodyPr>
+          <a:lstStyle/>
+          <a:p>
+            <a:pPr algn="l"/>
+            <a:r>
+              <a:rPr sz="1050" b="1" i="0">
+                <a:solidFill>
+                  <a:srgbClr val="29A9E0"/>
+                </a:solidFill>
+                <a:latin typeface="Arial"/>
+              </a:rPr>
+              <a:t>Prix médian</a:t>
+            </a:r>
+          </a:p>
+        </p:txBody>
+      </p:sp>
+      <p:sp>
+        <p:nvSpPr>
+          <p:cNvPr id="23" name="TextBox 22"/>
+          <p:cNvSpPr txBox="1"/>
+          <p:nvPr/>
+        </p:nvSpPr>
+        <p:spPr>
+          <a:xfrm>
+            <a:off x="5577840" y="1933956"/>
+            <a:ext cx="1691639" cy="237744"/>
+          </a:xfrm>
+          <a:prstGeom prst="rect">
+            <a:avLst/>
+          </a:prstGeom>
+          <a:noFill/>
+        </p:spPr>
+        <p:txBody>
+          <a:bodyPr wrap="square" lIns="0" rIns="0" tIns="0" bIns="0" anchor="t">
+            <a:spAutoFit/>
+          </a:bodyPr>
+          <a:lstStyle/>
+          <a:p>
+            <a:pPr algn="l"/>
+            <a:r>
+              <a:rPr sz="900" b="0" i="0">
+                <a:solidFill>
+                  <a:srgbClr val="9AA3B2"/>
+                </a:solidFill>
+                <a:latin typeface="Arial"/>
+              </a:rPr>
+              <a:t>Moitié des jeux en dessous</a:t>
+            </a:r>
+          </a:p>
+        </p:txBody>
+      </p:sp>
+      <p:sp>
+        <p:nvSpPr>
+          <p:cNvPr id="24" name="TextBox 23"/>
+          <p:cNvSpPr txBox="1"/>
+          <p:nvPr/>
+        </p:nvSpPr>
+        <p:spPr>
+          <a:xfrm>
+            <a:off x="7132320" y="1714500"/>
+            <a:ext cx="1417320" cy="411480"/>
+          </a:xfrm>
+          <a:prstGeom prst="rect">
+            <a:avLst/>
+          </a:prstGeom>
+          <a:noFill/>
+        </p:spPr>
+        <p:txBody>
+          <a:bodyPr wrap="square" lIns="0" rIns="0" tIns="0" bIns="0" anchor="t">
+            <a:spAutoFit/>
+          </a:bodyPr>
+          <a:lstStyle/>
+          <a:p>
+            <a:pPr algn="r"/>
+            <a:r>
+              <a:rPr sz="1700" b="1" i="0">
+                <a:solidFill>
+                  <a:srgbClr val="29A9E0"/>
+                </a:solidFill>
+                <a:latin typeface="Arial Black"/>
+              </a:rPr>
+              <a:t>5,99 €</a:t>
+            </a:r>
+          </a:p>
+        </p:txBody>
+      </p:sp>
+      <p:sp>
+        <p:nvSpPr>
+          <p:cNvPr id="25" name="Rounded Rectangle 24"/>
+          <p:cNvSpPr/>
+          <p:nvPr/>
+        </p:nvSpPr>
+        <p:spPr>
+          <a:xfrm>
+            <a:off x="5440680" y="2386584"/>
+            <a:ext cx="3246120" cy="640080"/>
+          </a:xfrm>
+          <a:prstGeom prst="roundRect">
+            <a:avLst>
+              <a:gd name="adj" fmla="val 10000"/>
+            </a:avLst>
+          </a:prstGeom>
+          <a:solidFill>
+            <a:srgbClr val="14243C"/>
+          </a:solidFill>
+          <a:ln w="15240">
+            <a:solidFill>
+              <a:srgbClr val="29A9E0"/>
+            </a:solidFill>
+          </a:ln>
+          <a:effectLst/>
+        </p:spPr>
+        <p:style>
+          <a:lnRef idx="1">
+            <a:schemeClr val="accent1"/>
+          </a:lnRef>
+          <a:fillRef idx="3">
+            <a:schemeClr val="accent1"/>
+          </a:fillRef>
+          <a:effectRef idx="2">
+            <a:schemeClr val="accent1"/>
+          </a:effectRef>
+          <a:fontRef idx="minor">
+            <a:schemeClr val="lt1"/>
+          </a:fontRef>
+        </p:style>
+        <p:txBody>
+          <a:bodyPr rtlCol="0" anchor="ctr"/>
+          <a:lstStyle/>
+          <a:p>
+            <a:pPr algn="ctr"/>
+          </a:p>
+        </p:txBody>
+      </p:sp>
+      <p:sp>
+        <p:nvSpPr>
+          <p:cNvPr id="26" name="TextBox 25"/>
+          <p:cNvSpPr txBox="1"/>
+          <p:nvPr/>
+        </p:nvSpPr>
+        <p:spPr>
+          <a:xfrm>
+            <a:off x="5577840" y="2418588"/>
+            <a:ext cx="1691639" cy="256032"/>
+          </a:xfrm>
+          <a:prstGeom prst="rect">
+            <a:avLst/>
+          </a:prstGeom>
+          <a:noFill/>
+        </p:spPr>
+        <p:txBody>
+          <a:bodyPr wrap="square" lIns="0" rIns="0" tIns="0" bIns="0" anchor="t">
+            <a:spAutoFit/>
+          </a:bodyPr>
+          <a:lstStyle/>
+          <a:p>
+            <a:pPr algn="l"/>
+            <a:r>
+              <a:rPr sz="1050" b="1" i="0">
+                <a:solidFill>
+                  <a:srgbClr val="29A9E0"/>
+                </a:solidFill>
+                <a:latin typeface="Arial"/>
+              </a:rPr>
+              <a:t>Prix moyen</a:t>
+            </a:r>
+          </a:p>
+        </p:txBody>
+      </p:sp>
+      <p:sp>
+        <p:nvSpPr>
+          <p:cNvPr id="27" name="TextBox 26"/>
+          <p:cNvSpPr txBox="1"/>
+          <p:nvPr/>
+        </p:nvSpPr>
+        <p:spPr>
+          <a:xfrm>
+            <a:off x="5577840" y="2674620"/>
+            <a:ext cx="1691639" cy="237744"/>
+          </a:xfrm>
+          <a:prstGeom prst="rect">
+            <a:avLst/>
+          </a:prstGeom>
+          <a:noFill/>
+        </p:spPr>
+        <p:txBody>
+          <a:bodyPr wrap="square" lIns="0" rIns="0" tIns="0" bIns="0" anchor="t">
+            <a:spAutoFit/>
+          </a:bodyPr>
+          <a:lstStyle/>
+          <a:p>
+            <a:pPr algn="l"/>
+            <a:r>
+              <a:rPr sz="900" b="0" i="0">
+                <a:solidFill>
+                  <a:srgbClr val="9AA3B2"/>
+                </a:solidFill>
+                <a:latin typeface="Arial"/>
+              </a:rPr>
+              <a:t>Tiré par de rares gros prix</a:t>
+            </a:r>
+          </a:p>
+        </p:txBody>
+      </p:sp>
+      <p:sp>
+        <p:nvSpPr>
+          <p:cNvPr id="28" name="TextBox 27"/>
+          <p:cNvSpPr txBox="1"/>
+          <p:nvPr/>
+        </p:nvSpPr>
+        <p:spPr>
+          <a:xfrm>
+            <a:off x="7132320" y="2455164"/>
+            <a:ext cx="1417320" cy="411480"/>
+          </a:xfrm>
+          <a:prstGeom prst="rect">
+            <a:avLst/>
+          </a:prstGeom>
+          <a:noFill/>
+        </p:spPr>
+        <p:txBody>
+          <a:bodyPr wrap="square" lIns="0" rIns="0" tIns="0" bIns="0" anchor="t">
+            <a:spAutoFit/>
+          </a:bodyPr>
+          <a:lstStyle/>
+          <a:p>
+            <a:pPr algn="r"/>
+            <a:r>
+              <a:rPr sz="1700" b="1" i="0">
+                <a:solidFill>
+                  <a:srgbClr val="29A9E0"/>
+                </a:solidFill>
+                <a:latin typeface="Arial Black"/>
+              </a:rPr>
+              <a:t>9,37 €</a:t>
+            </a:r>
+          </a:p>
+        </p:txBody>
+      </p:sp>
+      <p:sp>
+        <p:nvSpPr>
+          <p:cNvPr id="29" name="Rounded Rectangle 28"/>
+          <p:cNvSpPr/>
+          <p:nvPr/>
+        </p:nvSpPr>
+        <p:spPr>
+          <a:xfrm>
+            <a:off x="5440680" y="3127248"/>
+            <a:ext cx="3246120" cy="640080"/>
+          </a:xfrm>
+          <a:prstGeom prst="roundRect">
+            <a:avLst>
+              <a:gd name="adj" fmla="val 10000"/>
+            </a:avLst>
+          </a:prstGeom>
+          <a:solidFill>
+            <a:srgbClr val="14243C"/>
+          </a:solidFill>
+          <a:ln w="15240">
+            <a:solidFill>
+              <a:srgbClr val="F2C719"/>
+            </a:solidFill>
+          </a:ln>
+          <a:effectLst/>
+        </p:spPr>
+        <p:style>
+          <a:lnRef idx="1">
+            <a:schemeClr val="accent1"/>
+          </a:lnRef>
+          <a:fillRef idx="3">
+            <a:schemeClr val="accent1"/>
+          </a:fillRef>
+          <a:effectRef idx="2">
+            <a:schemeClr val="accent1"/>
+          </a:effectRef>
+          <a:fontRef idx="minor">
+            <a:schemeClr val="lt1"/>
+          </a:fontRef>
+        </p:style>
+        <p:txBody>
+          <a:bodyPr rtlCol="0" anchor="ctr"/>
+          <a:lstStyle/>
+          <a:p>
+            <a:pPr algn="ctr"/>
+          </a:p>
+        </p:txBody>
+      </p:sp>
+      <p:sp>
+        <p:nvSpPr>
+          <p:cNvPr id="30" name="TextBox 29"/>
+          <p:cNvSpPr txBox="1"/>
+          <p:nvPr/>
+        </p:nvSpPr>
+        <p:spPr>
+          <a:xfrm>
+            <a:off x="5577840" y="3159252"/>
+            <a:ext cx="1691639" cy="256032"/>
+          </a:xfrm>
+          <a:prstGeom prst="rect">
+            <a:avLst/>
+          </a:prstGeom>
+          <a:noFill/>
+        </p:spPr>
+        <p:txBody>
+          <a:bodyPr wrap="square" lIns="0" rIns="0" tIns="0" bIns="0" anchor="t">
+            <a:spAutoFit/>
+          </a:bodyPr>
+          <a:lstStyle/>
+          <a:p>
+            <a:pPr algn="l"/>
+            <a:r>
+              <a:rPr sz="1050" b="1" i="0">
+                <a:solidFill>
+                  <a:srgbClr val="F2C719"/>
+                </a:solidFill>
+                <a:latin typeface="Arial"/>
+              </a:rPr>
+              <a:t>Sous 10 €</a:t>
+            </a:r>
+          </a:p>
+        </p:txBody>
+      </p:sp>
+      <p:sp>
+        <p:nvSpPr>
+          <p:cNvPr id="31" name="TextBox 30"/>
+          <p:cNvSpPr txBox="1"/>
+          <p:nvPr/>
+        </p:nvSpPr>
+        <p:spPr>
+          <a:xfrm>
+            <a:off x="5577840" y="3415284"/>
+            <a:ext cx="1691639" cy="237744"/>
+          </a:xfrm>
+          <a:prstGeom prst="rect">
+            <a:avLst/>
+          </a:prstGeom>
+          <a:noFill/>
+        </p:spPr>
+        <p:txBody>
+          <a:bodyPr wrap="square" lIns="0" rIns="0" tIns="0" bIns="0" anchor="t">
+            <a:spAutoFit/>
+          </a:bodyPr>
+          <a:lstStyle/>
+          <a:p>
+            <a:pPr algn="l"/>
+            <a:r>
+              <a:rPr sz="900" b="0" i="0">
+                <a:solidFill>
+                  <a:srgbClr val="9AA3B2"/>
+                </a:solidFill>
+                <a:latin typeface="Arial"/>
+              </a:rPr>
+              <a:t>La majorité du marché</a:t>
+            </a:r>
+          </a:p>
+        </p:txBody>
+      </p:sp>
+      <p:sp>
+        <p:nvSpPr>
+          <p:cNvPr id="32" name="TextBox 31"/>
+          <p:cNvSpPr txBox="1"/>
+          <p:nvPr/>
+        </p:nvSpPr>
+        <p:spPr>
+          <a:xfrm>
+            <a:off x="7132320" y="3195828"/>
+            <a:ext cx="1417320" cy="411480"/>
+          </a:xfrm>
+          <a:prstGeom prst="rect">
+            <a:avLst/>
+          </a:prstGeom>
+          <a:noFill/>
+        </p:spPr>
+        <p:txBody>
+          <a:bodyPr wrap="square" lIns="0" rIns="0" tIns="0" bIns="0" anchor="t">
+            <a:spAutoFit/>
+          </a:bodyPr>
+          <a:lstStyle/>
+          <a:p>
+            <a:pPr algn="r"/>
+            <a:r>
+              <a:rPr sz="1700" b="1" i="0">
+                <a:solidFill>
+                  <a:srgbClr val="F2C719"/>
+                </a:solidFill>
+                <a:latin typeface="Arial Black"/>
+              </a:rPr>
+              <a:t>72,6 %</a:t>
+            </a:r>
+          </a:p>
+        </p:txBody>
+      </p:sp>
+      <p:sp>
+        <p:nvSpPr>
+          <p:cNvPr id="33" name="Rounded Rectangle 32"/>
+          <p:cNvSpPr/>
+          <p:nvPr/>
+        </p:nvSpPr>
+        <p:spPr>
+          <a:xfrm>
+            <a:off x="5440680" y="3867912"/>
+            <a:ext cx="3246120" cy="640080"/>
+          </a:xfrm>
+          <a:prstGeom prst="roundRect">
+            <a:avLst>
+              <a:gd name="adj" fmla="val 10000"/>
+            </a:avLst>
+          </a:prstGeom>
+          <a:solidFill>
+            <a:srgbClr val="14243C"/>
+          </a:solidFill>
+          <a:ln w="15240">
+            <a:solidFill>
+              <a:srgbClr val="47B25B"/>
+            </a:solidFill>
+          </a:ln>
+          <a:effectLst/>
+        </p:spPr>
+        <p:style>
+          <a:lnRef idx="1">
+            <a:schemeClr val="accent1"/>
+          </a:lnRef>
+          <a:fillRef idx="3">
+            <a:schemeClr val="accent1"/>
+          </a:fillRef>
+          <a:effectRef idx="2">
+            <a:schemeClr val="accent1"/>
+          </a:effectRef>
+          <a:fontRef idx="minor">
+            <a:schemeClr val="lt1"/>
+          </a:fontRef>
+        </p:style>
+        <p:txBody>
+          <a:bodyPr rtlCol="0" anchor="ctr"/>
+          <a:lstStyle/>
+          <a:p>
+            <a:pPr algn="ctr"/>
+          </a:p>
+        </p:txBody>
+      </p:sp>
+      <p:sp>
+        <p:nvSpPr>
+          <p:cNvPr id="34" name="TextBox 33"/>
+          <p:cNvSpPr txBox="1"/>
+          <p:nvPr/>
+        </p:nvSpPr>
+        <p:spPr>
+          <a:xfrm>
+            <a:off x="5577840" y="3899916"/>
+            <a:ext cx="1691639" cy="256032"/>
+          </a:xfrm>
+          <a:prstGeom prst="rect">
+            <a:avLst/>
+          </a:prstGeom>
+          <a:noFill/>
+        </p:spPr>
+        <p:txBody>
+          <a:bodyPr wrap="square" lIns="0" rIns="0" tIns="0" bIns="0" anchor="t">
+            <a:spAutoFit/>
+          </a:bodyPr>
+          <a:lstStyle/>
+          <a:p>
+            <a:pPr algn="l"/>
+            <a:r>
+              <a:rPr sz="1050" b="1" i="0">
+                <a:solidFill>
+                  <a:srgbClr val="47B25B"/>
+                </a:solidFill>
+                <a:latin typeface="Arial"/>
+              </a:rPr>
+              <a:t>Sous 20 €</a:t>
+            </a:r>
+          </a:p>
+        </p:txBody>
+      </p:sp>
+      <p:sp>
+        <p:nvSpPr>
+          <p:cNvPr id="35" name="TextBox 34"/>
+          <p:cNvSpPr txBox="1"/>
+          <p:nvPr/>
+        </p:nvSpPr>
+        <p:spPr>
+          <a:xfrm>
+            <a:off x="5577840" y="4155948"/>
+            <a:ext cx="1691639" cy="237744"/>
+          </a:xfrm>
+          <a:prstGeom prst="rect">
+            <a:avLst/>
+          </a:prstGeom>
+          <a:noFill/>
+        </p:spPr>
+        <p:txBody>
+          <a:bodyPr wrap="square" lIns="0" rIns="0" tIns="0" bIns="0" anchor="t">
+            <a:spAutoFit/>
+          </a:bodyPr>
+          <a:lstStyle/>
+          <a:p>
+            <a:pPr algn="l"/>
+            <a:r>
+              <a:rPr sz="900" b="0" i="0">
+                <a:solidFill>
+                  <a:srgbClr val="9AA3B2"/>
+                </a:solidFill>
+                <a:latin typeface="Arial"/>
+              </a:rPr>
+              <a:t>Quasi tout le catalogue</a:t>
+            </a:r>
+          </a:p>
+        </p:txBody>
+      </p:sp>
+      <p:sp>
+        <p:nvSpPr>
+          <p:cNvPr id="36" name="TextBox 35"/>
+          <p:cNvSpPr txBox="1"/>
+          <p:nvPr/>
+        </p:nvSpPr>
+        <p:spPr>
+          <a:xfrm>
+            <a:off x="7132320" y="3936492"/>
+            <a:ext cx="1417320" cy="411480"/>
+          </a:xfrm>
+          <a:prstGeom prst="rect">
+            <a:avLst/>
+          </a:prstGeom>
+          <a:noFill/>
+        </p:spPr>
+        <p:txBody>
+          <a:bodyPr wrap="square" lIns="0" rIns="0" tIns="0" bIns="0" anchor="t">
+            <a:spAutoFit/>
+          </a:bodyPr>
+          <a:lstStyle/>
+          <a:p>
+            <a:pPr algn="r"/>
+            <a:r>
+              <a:rPr sz="1700" b="1" i="0">
+                <a:solidFill>
+                  <a:srgbClr val="47B25B"/>
+                </a:solidFill>
+                <a:latin typeface="Arial Black"/>
+              </a:rPr>
+              <a:t>93,4 %</a:t>
+            </a:r>
+          </a:p>
+        </p:txBody>
+      </p:sp>
+      <p:sp>
+        <p:nvSpPr>
+          <p:cNvPr id="37" name="TextBox 36"/>
+          <p:cNvSpPr txBox="1"/>
+          <p:nvPr/>
+        </p:nvSpPr>
+        <p:spPr>
+          <a:xfrm>
+            <a:off x="457200" y="4736592"/>
+            <a:ext cx="8229600" cy="320040"/>
+          </a:xfrm>
+          <a:prstGeom prst="rect">
+            <a:avLst/>
+          </a:prstGeom>
+          <a:noFill/>
+        </p:spPr>
+        <p:txBody>
+          <a:bodyPr wrap="square" lIns="0" rIns="0" tIns="0" bIns="0" anchor="t">
+            <a:spAutoFit/>
+          </a:bodyPr>
+          <a:lstStyle/>
+          <a:p>
+            <a:pPr algn="l"/>
+            <a:r>
+              <a:rPr sz="1000" b="0" i="1">
+                <a:solidFill>
+                  <a:srgbClr val="EF3E5C"/>
+                </a:solidFill>
+                <a:latin typeface="Arial"/>
+              </a:rPr>
+              <a:t>Insight : le marché se concentre sous 10 euros (médiane 5,99 €). Un positionnement 10-20 € situe une IP majeure au-dessus du segment saturé, sans quitter les 93 % du marché.</a:t>
+            </a:r>
+          </a:p>
+        </p:txBody>
+      </p:sp>
+    </p:spTree>
+  </p:cSld>
+  <p:clrMapOvr>
+    <a:masterClrMapping/>
+  </p:clrMapOvr>
+</p:sld>
+</file>
+
+<file path=ppt/slides/slide12.xml><?xml version="1.0" encoding="utf-8"?>
+<p:sld xmlns:a="http://schemas.openxmlformats.org/drawingml/2006/main" xmlns:p="http://schemas.openxmlformats.org/presentationml/2006/main" xmlns:r="http://schemas.openxmlformats.org/officeDocument/2006/relationships">
+  <p:cSld>
+    <p:spTree>
+      <p:nvGrpSpPr>
+        <p:cNvPr id="1" name=""/>
+        <p:cNvGrpSpPr/>
+        <p:nvPr/>
+      </p:nvGrpSpPr>
+      <p:grpSpPr/>
+      <p:sp>
+        <p:nvSpPr>
+          <p:cNvPr id="2" name="TextBox 1"/>
+          <p:cNvSpPr txBox="1"/>
+          <p:nvPr/>
+        </p:nvSpPr>
+        <p:spPr>
+          <a:xfrm>
+            <a:off x="457200" y="256032"/>
+            <a:ext cx="7772400" cy="274320"/>
+          </a:xfrm>
+          <a:prstGeom prst="rect">
+            <a:avLst/>
+          </a:prstGeom>
+          <a:noFill/>
+        </p:spPr>
+        <p:txBody>
+          <a:bodyPr wrap="square" lIns="0" rIns="0" tIns="0" bIns="0" anchor="t">
+            <a:spAutoFit/>
+          </a:bodyPr>
+          <a:lstStyle/>
+          <a:p>
+            <a:pPr algn="l"/>
+            <a:r>
+              <a:rPr sz="1100" b="1" i="0">
+                <a:solidFill>
+                  <a:srgbClr val="29A9E0"/>
+                </a:solidFill>
+                <a:latin typeface="Arial"/>
+              </a:rPr>
+              <a:t>A N A L Y S E   D E S   P L A T E F O R M E S   -   2 / 2</a:t>
+            </a:r>
+          </a:p>
+        </p:txBody>
+      </p:sp>
+      <p:sp>
+        <p:nvSpPr>
+          <p:cNvPr id="3" name="TextBox 2"/>
+          <p:cNvSpPr txBox="1"/>
+          <p:nvPr/>
+        </p:nvSpPr>
+        <p:spPr>
+          <a:xfrm>
+            <a:off x="420624" y="502920"/>
+            <a:ext cx="8229600" cy="777240"/>
+          </a:xfrm>
+          <a:prstGeom prst="rect">
+            <a:avLst/>
+          </a:prstGeom>
+          <a:noFill/>
+        </p:spPr>
+        <p:txBody>
+          <a:bodyPr wrap="square" lIns="0" rIns="0" tIns="0" bIns="0" anchor="t">
+            <a:spAutoFit/>
+          </a:bodyPr>
+          <a:lstStyle/>
+          <a:p>
+            <a:pPr algn="l"/>
+            <a:r>
+              <a:rPr sz="3400" b="1" i="0">
+                <a:solidFill>
+                  <a:srgbClr val="FFFFFF"/>
+                </a:solidFill>
+                <a:latin typeface="Arial Black"/>
+              </a:rPr>
+              <a:t>Mac et Linux selon le genre</a:t>
+            </a:r>
+          </a:p>
+        </p:txBody>
+      </p:sp>
+      <p:sp>
+        <p:nvSpPr>
+          <p:cNvPr id="4" name="TextBox 3"/>
+          <p:cNvSpPr txBox="1"/>
+          <p:nvPr/>
+        </p:nvSpPr>
+        <p:spPr>
+          <a:xfrm>
+            <a:off x="457200" y="1325880"/>
+            <a:ext cx="4572000" cy="274320"/>
+          </a:xfrm>
+          <a:prstGeom prst="rect">
+            <a:avLst/>
+          </a:prstGeom>
+          <a:noFill/>
+        </p:spPr>
+        <p:txBody>
+          <a:bodyPr wrap="square" lIns="0" rIns="0" tIns="0" bIns="0" anchor="t">
+            <a:spAutoFit/>
+          </a:bodyPr>
+          <a:lstStyle/>
+          <a:p>
+            <a:pPr algn="l"/>
+            <a:r>
+              <a:rPr sz="1300" b="1" i="0">
+                <a:solidFill>
+                  <a:srgbClr val="29A9E0"/>
+                </a:solidFill>
+                <a:latin typeface="Arial"/>
+              </a:rPr>
+              <a:t>Part des jeux compatibles (%)</a:t>
+            </a:r>
+          </a:p>
+        </p:txBody>
+      </p:sp>
+      <p:sp>
+        <p:nvSpPr>
+          <p:cNvPr id="5" name="Rounded Rectangle 4"/>
+          <p:cNvSpPr/>
+          <p:nvPr/>
+        </p:nvSpPr>
+        <p:spPr>
+          <a:xfrm>
+            <a:off x="457200" y="1645920"/>
+            <a:ext cx="4754880" cy="2880360"/>
+          </a:xfrm>
+          <a:prstGeom prst="roundRect">
+            <a:avLst>
+              <a:gd name="adj" fmla="val 5000"/>
+            </a:avLst>
+          </a:prstGeom>
+          <a:solidFill>
+            <a:srgbClr val="16263F"/>
+          </a:solidFill>
+          <a:ln w="12700">
+            <a:solidFill>
+              <a:srgbClr val="24344F"/>
+            </a:solidFill>
+          </a:ln>
+          <a:effectLst/>
+        </p:spPr>
+        <p:style>
+          <a:lnRef idx="1">
+            <a:schemeClr val="accent1"/>
+          </a:lnRef>
+          <a:fillRef idx="3">
+            <a:schemeClr val="accent1"/>
+          </a:fillRef>
+          <a:effectRef idx="2">
+            <a:schemeClr val="accent1"/>
+          </a:effectRef>
+          <a:fontRef idx="minor">
+            <a:schemeClr val="lt1"/>
+          </a:fontRef>
+        </p:style>
+        <p:txBody>
+          <a:bodyPr rtlCol="0" anchor="ctr"/>
+          <a:lstStyle/>
+          <a:p>
+            <a:pPr algn="ctr"/>
+          </a:p>
+        </p:txBody>
+      </p:sp>
+      <p:sp>
+        <p:nvSpPr>
+          <p:cNvPr id="6" name="TextBox 5"/>
+          <p:cNvSpPr txBox="1"/>
+          <p:nvPr/>
+        </p:nvSpPr>
+        <p:spPr>
+          <a:xfrm>
+            <a:off x="566928" y="1883664"/>
+            <a:ext cx="1325880" cy="274320"/>
+          </a:xfrm>
+          <a:prstGeom prst="rect">
+            <a:avLst/>
+          </a:prstGeom>
+          <a:noFill/>
+        </p:spPr>
+        <p:txBody>
+          <a:bodyPr wrap="square" lIns="0" rIns="0" tIns="0" bIns="0" anchor="t">
+            <a:spAutoFit/>
+          </a:bodyPr>
+          <a:lstStyle/>
+          <a:p>
+            <a:pPr algn="l"/>
+            <a:r>
+              <a:rPr sz="950" b="0" i="0">
+                <a:solidFill>
+                  <a:srgbClr val="FFFFFF"/>
+                </a:solidFill>
+                <a:latin typeface="Arial"/>
+              </a:rPr>
+              <a:t>Game Development</a:t>
+            </a:r>
+          </a:p>
+        </p:txBody>
+      </p:sp>
+      <p:sp>
+        <p:nvSpPr>
+          <p:cNvPr id="7" name="Rectangle 6"/>
+          <p:cNvSpPr/>
+          <p:nvPr/>
+        </p:nvSpPr>
+        <p:spPr>
+          <a:xfrm>
+            <a:off x="1965960" y="1865376"/>
+            <a:ext cx="2219913" cy="141732"/>
+          </a:xfrm>
+          <a:prstGeom prst="rect">
+            <a:avLst/>
+          </a:prstGeom>
+          <a:solidFill>
+            <a:srgbClr val="29A9E0"/>
+          </a:solidFill>
+          <a:ln>
+            <a:noFill/>
+          </a:ln>
+          <a:effectLst/>
+        </p:spPr>
+        <p:style>
+          <a:lnRef idx="1">
+            <a:schemeClr val="accent1"/>
+          </a:lnRef>
+          <a:fillRef idx="3">
+            <a:schemeClr val="accent1"/>
+          </a:fillRef>
+          <a:effectRef idx="2">
+            <a:schemeClr val="accent1"/>
+          </a:effectRef>
+          <a:fontRef idx="minor">
+            <a:schemeClr val="lt1"/>
+          </a:fontRef>
+        </p:style>
+        <p:txBody>
+          <a:bodyPr rtlCol="0" anchor="ctr"/>
+          <a:lstStyle/>
+          <a:p>
+            <a:pPr algn="ctr"/>
+          </a:p>
+        </p:txBody>
+      </p:sp>
+      <p:sp>
+        <p:nvSpPr>
+          <p:cNvPr id="8" name="TextBox 7"/>
+          <p:cNvSpPr txBox="1"/>
+          <p:nvPr/>
+        </p:nvSpPr>
+        <p:spPr>
+          <a:xfrm>
+            <a:off x="4240737" y="1837944"/>
+            <a:ext cx="777240" cy="219456"/>
+          </a:xfrm>
+          <a:prstGeom prst="rect">
+            <a:avLst/>
+          </a:prstGeom>
+          <a:noFill/>
+        </p:spPr>
+        <p:txBody>
+          <a:bodyPr wrap="square" lIns="0" rIns="0" tIns="0" bIns="0" anchor="t">
+            <a:spAutoFit/>
+          </a:bodyPr>
+          <a:lstStyle/>
+          <a:p>
+            <a:pPr algn="l"/>
+            <a:r>
+              <a:rPr sz="850" b="0" i="0">
+                <a:solidFill>
+                  <a:srgbClr val="D7DCE6"/>
+                </a:solidFill>
+                <a:latin typeface="Arial"/>
+              </a:rPr>
+              <a:t>33 %</a:t>
+            </a:r>
+          </a:p>
+        </p:txBody>
+      </p:sp>
+      <p:sp>
+        <p:nvSpPr>
+          <p:cNvPr id="9" name="Rectangle 8"/>
+          <p:cNvSpPr/>
+          <p:nvPr/>
+        </p:nvSpPr>
+        <p:spPr>
+          <a:xfrm>
+            <a:off x="1965960" y="2052828"/>
+            <a:ext cx="1493520" cy="141732"/>
+          </a:xfrm>
+          <a:prstGeom prst="rect">
+            <a:avLst/>
+          </a:prstGeom>
+          <a:solidFill>
+            <a:srgbClr val="47B25B"/>
+          </a:solidFill>
+          <a:ln>
+            <a:noFill/>
+          </a:ln>
+          <a:effectLst/>
+        </p:spPr>
+        <p:style>
+          <a:lnRef idx="1">
+            <a:schemeClr val="accent1"/>
+          </a:lnRef>
+          <a:fillRef idx="3">
+            <a:schemeClr val="accent1"/>
+          </a:fillRef>
+          <a:effectRef idx="2">
+            <a:schemeClr val="accent1"/>
+          </a:effectRef>
+          <a:fontRef idx="minor">
+            <a:schemeClr val="lt1"/>
+          </a:fontRef>
+        </p:style>
+        <p:txBody>
+          <a:bodyPr rtlCol="0" anchor="ctr"/>
+          <a:lstStyle/>
+          <a:p>
+            <a:pPr algn="ctr"/>
+          </a:p>
+        </p:txBody>
+      </p:sp>
+      <p:sp>
+        <p:nvSpPr>
+          <p:cNvPr id="10" name="TextBox 9"/>
+          <p:cNvSpPr txBox="1"/>
+          <p:nvPr/>
+        </p:nvSpPr>
+        <p:spPr>
+          <a:xfrm>
+            <a:off x="3514344" y="2025395"/>
+            <a:ext cx="777240" cy="219456"/>
+          </a:xfrm>
+          <a:prstGeom prst="rect">
+            <a:avLst/>
+          </a:prstGeom>
+          <a:noFill/>
+        </p:spPr>
+        <p:txBody>
+          <a:bodyPr wrap="square" lIns="0" rIns="0" tIns="0" bIns="0" anchor="t">
+            <a:spAutoFit/>
+          </a:bodyPr>
+          <a:lstStyle/>
+          <a:p>
+            <a:pPr algn="l"/>
+            <a:r>
+              <a:rPr sz="850" b="0" i="0">
+                <a:solidFill>
+                  <a:srgbClr val="D7DCE6"/>
+                </a:solidFill>
+                <a:latin typeface="Arial"/>
+              </a:rPr>
+              <a:t>22 %</a:t>
+            </a:r>
+          </a:p>
+        </p:txBody>
+      </p:sp>
+      <p:sp>
+        <p:nvSpPr>
+          <p:cNvPr id="11" name="TextBox 10"/>
+          <p:cNvSpPr txBox="1"/>
+          <p:nvPr/>
+        </p:nvSpPr>
+        <p:spPr>
+          <a:xfrm>
+            <a:off x="566928" y="2359152"/>
+            <a:ext cx="1325880" cy="274320"/>
+          </a:xfrm>
+          <a:prstGeom prst="rect">
+            <a:avLst/>
+          </a:prstGeom>
+          <a:noFill/>
+        </p:spPr>
+        <p:txBody>
+          <a:bodyPr wrap="square" lIns="0" rIns="0" tIns="0" bIns="0" anchor="t">
+            <a:spAutoFit/>
+          </a:bodyPr>
+          <a:lstStyle/>
+          <a:p>
+            <a:pPr algn="l"/>
+            <a:r>
+              <a:rPr sz="950" b="0" i="0">
+                <a:solidFill>
+                  <a:srgbClr val="FFFFFF"/>
+                </a:solidFill>
+                <a:latin typeface="Arial"/>
+              </a:rPr>
+              <a:t>Strategy</a:t>
+            </a:r>
+          </a:p>
+        </p:txBody>
+      </p:sp>
+      <p:sp>
+        <p:nvSpPr>
+          <p:cNvPr id="12" name="Rectangle 11"/>
+          <p:cNvSpPr/>
+          <p:nvPr/>
+        </p:nvSpPr>
+        <p:spPr>
+          <a:xfrm>
+            <a:off x="1965960" y="2340864"/>
+            <a:ext cx="1873688" cy="141732"/>
+          </a:xfrm>
+          <a:prstGeom prst="rect">
+            <a:avLst/>
+          </a:prstGeom>
+          <a:solidFill>
+            <a:srgbClr val="29A9E0"/>
+          </a:solidFill>
+          <a:ln>
+            <a:noFill/>
+          </a:ln>
+          <a:effectLst/>
+        </p:spPr>
+        <p:style>
+          <a:lnRef idx="1">
+            <a:schemeClr val="accent1"/>
+          </a:lnRef>
+          <a:fillRef idx="3">
+            <a:schemeClr val="accent1"/>
+          </a:fillRef>
+          <a:effectRef idx="2">
+            <a:schemeClr val="accent1"/>
+          </a:effectRef>
+          <a:fontRef idx="minor">
+            <a:schemeClr val="lt1"/>
+          </a:fontRef>
+        </p:style>
+        <p:txBody>
+          <a:bodyPr rtlCol="0" anchor="ctr"/>
+          <a:lstStyle/>
+          <a:p>
+            <a:pPr algn="ctr"/>
+          </a:p>
+        </p:txBody>
+      </p:sp>
+      <p:sp>
+        <p:nvSpPr>
+          <p:cNvPr id="13" name="TextBox 12"/>
+          <p:cNvSpPr txBox="1"/>
+          <p:nvPr/>
+        </p:nvSpPr>
+        <p:spPr>
+          <a:xfrm>
+            <a:off x="3894512" y="2313432"/>
+            <a:ext cx="777240" cy="219456"/>
+          </a:xfrm>
+          <a:prstGeom prst="rect">
+            <a:avLst/>
+          </a:prstGeom>
+          <a:noFill/>
+        </p:spPr>
+        <p:txBody>
+          <a:bodyPr wrap="square" lIns="0" rIns="0" tIns="0" bIns="0" anchor="t">
+            <a:spAutoFit/>
+          </a:bodyPr>
+          <a:lstStyle/>
+          <a:p>
+            <a:pPr algn="l"/>
+            <a:r>
+              <a:rPr sz="850" b="0" i="0">
+                <a:solidFill>
+                  <a:srgbClr val="D7DCE6"/>
+                </a:solidFill>
+                <a:latin typeface="Arial"/>
+              </a:rPr>
+              <a:t>28 %</a:t>
+            </a:r>
+          </a:p>
+        </p:txBody>
+      </p:sp>
+      <p:sp>
+        <p:nvSpPr>
+          <p:cNvPr id="14" name="Rectangle 13"/>
+          <p:cNvSpPr/>
+          <p:nvPr/>
+        </p:nvSpPr>
+        <p:spPr>
+          <a:xfrm>
+            <a:off x="1965960" y="2528316"/>
+            <a:ext cx="1140506" cy="141732"/>
+          </a:xfrm>
+          <a:prstGeom prst="rect">
+            <a:avLst/>
+          </a:prstGeom>
+          <a:solidFill>
+            <a:srgbClr val="47B25B"/>
+          </a:solidFill>
+          <a:ln>
+            <a:noFill/>
+          </a:ln>
+          <a:effectLst/>
+        </p:spPr>
+        <p:style>
+          <a:lnRef idx="1">
+            <a:schemeClr val="accent1"/>
+          </a:lnRef>
+          <a:fillRef idx="3">
+            <a:schemeClr val="accent1"/>
+          </a:fillRef>
+          <a:effectRef idx="2">
+            <a:schemeClr val="accent1"/>
+          </a:effectRef>
+          <a:fontRef idx="minor">
+            <a:schemeClr val="lt1"/>
+          </a:fontRef>
+        </p:style>
+        <p:txBody>
+          <a:bodyPr rtlCol="0" anchor="ctr"/>
+          <a:lstStyle/>
+          <a:p>
+            <a:pPr algn="ctr"/>
+          </a:p>
+        </p:txBody>
+      </p:sp>
+      <p:sp>
+        <p:nvSpPr>
+          <p:cNvPr id="15" name="TextBox 14"/>
+          <p:cNvSpPr txBox="1"/>
+          <p:nvPr/>
+        </p:nvSpPr>
+        <p:spPr>
+          <a:xfrm>
+            <a:off x="3161330" y="2500884"/>
+            <a:ext cx="777240" cy="219456"/>
+          </a:xfrm>
+          <a:prstGeom prst="rect">
+            <a:avLst/>
+          </a:prstGeom>
+          <a:noFill/>
+        </p:spPr>
+        <p:txBody>
+          <a:bodyPr wrap="square" lIns="0" rIns="0" tIns="0" bIns="0" anchor="t">
+            <a:spAutoFit/>
+          </a:bodyPr>
+          <a:lstStyle/>
+          <a:p>
+            <a:pPr algn="l"/>
+            <a:r>
+              <a:rPr sz="850" b="0" i="0">
+                <a:solidFill>
+                  <a:srgbClr val="D7DCE6"/>
+                </a:solidFill>
+                <a:latin typeface="Arial"/>
+              </a:rPr>
+              <a:t>17 %</a:t>
+            </a:r>
+          </a:p>
+        </p:txBody>
+      </p:sp>
+      <p:sp>
+        <p:nvSpPr>
+          <p:cNvPr id="16" name="TextBox 15"/>
+          <p:cNvSpPr txBox="1"/>
+          <p:nvPr/>
+        </p:nvSpPr>
+        <p:spPr>
+          <a:xfrm>
+            <a:off x="566928" y="2834640"/>
+            <a:ext cx="1325880" cy="274320"/>
+          </a:xfrm>
+          <a:prstGeom prst="rect">
+            <a:avLst/>
+          </a:prstGeom>
+          <a:noFill/>
+        </p:spPr>
+        <p:txBody>
+          <a:bodyPr wrap="square" lIns="0" rIns="0" tIns="0" bIns="0" anchor="t">
+            <a:spAutoFit/>
+          </a:bodyPr>
+          <a:lstStyle/>
+          <a:p>
+            <a:pPr algn="l"/>
+            <a:r>
+              <a:rPr sz="950" b="0" i="0">
+                <a:solidFill>
+                  <a:srgbClr val="FFFFFF"/>
+                </a:solidFill>
+                <a:latin typeface="Arial"/>
+              </a:rPr>
+              <a:t>Indie</a:t>
+            </a:r>
+          </a:p>
+        </p:txBody>
+      </p:sp>
+      <p:sp>
+        <p:nvSpPr>
+          <p:cNvPr id="17" name="Rectangle 16"/>
+          <p:cNvSpPr/>
+          <p:nvPr/>
+        </p:nvSpPr>
+        <p:spPr>
+          <a:xfrm>
+            <a:off x="1965960" y="2816352"/>
+            <a:ext cx="1697181" cy="141732"/>
+          </a:xfrm>
+          <a:prstGeom prst="rect">
+            <a:avLst/>
+          </a:prstGeom>
+          <a:solidFill>
+            <a:srgbClr val="29A9E0"/>
+          </a:solidFill>
+          <a:ln>
+            <a:noFill/>
+          </a:ln>
+          <a:effectLst/>
+        </p:spPr>
+        <p:style>
+          <a:lnRef idx="1">
+            <a:schemeClr val="accent1"/>
+          </a:lnRef>
+          <a:fillRef idx="3">
+            <a:schemeClr val="accent1"/>
+          </a:fillRef>
+          <a:effectRef idx="2">
+            <a:schemeClr val="accent1"/>
+          </a:effectRef>
+          <a:fontRef idx="minor">
+            <a:schemeClr val="lt1"/>
+          </a:fontRef>
+        </p:style>
+        <p:txBody>
+          <a:bodyPr rtlCol="0" anchor="ctr"/>
+          <a:lstStyle/>
+          <a:p>
+            <a:pPr algn="ctr"/>
+          </a:p>
+        </p:txBody>
+      </p:sp>
+      <p:sp>
+        <p:nvSpPr>
+          <p:cNvPr id="18" name="TextBox 17"/>
+          <p:cNvSpPr txBox="1"/>
+          <p:nvPr/>
+        </p:nvSpPr>
+        <p:spPr>
+          <a:xfrm>
+            <a:off x="3718005" y="2788920"/>
+            <a:ext cx="777240" cy="219456"/>
+          </a:xfrm>
+          <a:prstGeom prst="rect">
+            <a:avLst/>
+          </a:prstGeom>
+          <a:noFill/>
+        </p:spPr>
+        <p:txBody>
+          <a:bodyPr wrap="square" lIns="0" rIns="0" tIns="0" bIns="0" anchor="t">
+            <a:spAutoFit/>
+          </a:bodyPr>
+          <a:lstStyle/>
+          <a:p>
+            <a:pPr algn="l"/>
+            <a:r>
+              <a:rPr sz="850" b="0" i="0">
+                <a:solidFill>
+                  <a:srgbClr val="D7DCE6"/>
+                </a:solidFill>
+                <a:latin typeface="Arial"/>
+              </a:rPr>
+              <a:t>25 %</a:t>
+            </a:r>
+          </a:p>
+        </p:txBody>
+      </p:sp>
+      <p:sp>
+        <p:nvSpPr>
+          <p:cNvPr id="19" name="Rectangle 18"/>
+          <p:cNvSpPr/>
+          <p:nvPr/>
+        </p:nvSpPr>
+        <p:spPr>
+          <a:xfrm>
+            <a:off x="1965960" y="3003804"/>
+            <a:ext cx="1194816" cy="141732"/>
+          </a:xfrm>
+          <a:prstGeom prst="rect">
+            <a:avLst/>
+          </a:prstGeom>
+          <a:solidFill>
+            <a:srgbClr val="47B25B"/>
+          </a:solidFill>
+          <a:ln>
+            <a:noFill/>
+          </a:ln>
+          <a:effectLst/>
+        </p:spPr>
+        <p:style>
+          <a:lnRef idx="1">
+            <a:schemeClr val="accent1"/>
+          </a:lnRef>
+          <a:fillRef idx="3">
+            <a:schemeClr val="accent1"/>
+          </a:fillRef>
+          <a:effectRef idx="2">
+            <a:schemeClr val="accent1"/>
+          </a:effectRef>
+          <a:fontRef idx="minor">
+            <a:schemeClr val="lt1"/>
+          </a:fontRef>
+        </p:style>
+        <p:txBody>
+          <a:bodyPr rtlCol="0" anchor="ctr"/>
+          <a:lstStyle/>
+          <a:p>
+            <a:pPr algn="ctr"/>
+          </a:p>
+        </p:txBody>
+      </p:sp>
+      <p:sp>
+        <p:nvSpPr>
+          <p:cNvPr id="20" name="TextBox 19"/>
+          <p:cNvSpPr txBox="1"/>
+          <p:nvPr/>
+        </p:nvSpPr>
+        <p:spPr>
+          <a:xfrm>
+            <a:off x="3215640" y="2976372"/>
+            <a:ext cx="777240" cy="219456"/>
+          </a:xfrm>
+          <a:prstGeom prst="rect">
+            <a:avLst/>
+          </a:prstGeom>
+          <a:noFill/>
+        </p:spPr>
+        <p:txBody>
+          <a:bodyPr wrap="square" lIns="0" rIns="0" tIns="0" bIns="0" anchor="t">
+            <a:spAutoFit/>
+          </a:bodyPr>
+          <a:lstStyle/>
+          <a:p>
+            <a:pPr algn="l"/>
+            <a:r>
+              <a:rPr sz="850" b="0" i="0">
+                <a:solidFill>
+                  <a:srgbClr val="D7DCE6"/>
+                </a:solidFill>
+                <a:latin typeface="Arial"/>
+              </a:rPr>
+              <a:t>18 %</a:t>
+            </a:r>
+          </a:p>
+        </p:txBody>
+      </p:sp>
+      <p:sp>
+        <p:nvSpPr>
+          <p:cNvPr id="21" name="TextBox 20"/>
+          <p:cNvSpPr txBox="1"/>
+          <p:nvPr/>
+        </p:nvSpPr>
+        <p:spPr>
+          <a:xfrm>
+            <a:off x="566928" y="3310128"/>
+            <a:ext cx="1325880" cy="274320"/>
+          </a:xfrm>
+          <a:prstGeom prst="rect">
+            <a:avLst/>
+          </a:prstGeom>
+          <a:noFill/>
+        </p:spPr>
+        <p:txBody>
+          <a:bodyPr wrap="square" lIns="0" rIns="0" tIns="0" bIns="0" anchor="t">
+            <a:spAutoFit/>
+          </a:bodyPr>
+          <a:lstStyle/>
+          <a:p>
+            <a:pPr algn="l"/>
+            <a:r>
+              <a:rPr sz="950" b="0" i="0">
+                <a:solidFill>
+                  <a:srgbClr val="FFFFFF"/>
+                </a:solidFill>
+                <a:latin typeface="Arial"/>
+              </a:rPr>
+              <a:t>Adventure</a:t>
+            </a:r>
+          </a:p>
+        </p:txBody>
+      </p:sp>
+      <p:sp>
+        <p:nvSpPr>
+          <p:cNvPr id="22" name="Rectangle 21"/>
+          <p:cNvSpPr/>
+          <p:nvPr/>
+        </p:nvSpPr>
+        <p:spPr>
+          <a:xfrm>
+            <a:off x="1965960" y="3291840"/>
+            <a:ext cx="1595350" cy="141732"/>
+          </a:xfrm>
+          <a:prstGeom prst="rect">
+            <a:avLst/>
+          </a:prstGeom>
+          <a:solidFill>
+            <a:srgbClr val="29A9E0"/>
+          </a:solidFill>
+          <a:ln>
+            <a:noFill/>
+          </a:ln>
+          <a:effectLst/>
+        </p:spPr>
+        <p:style>
+          <a:lnRef idx="1">
+            <a:schemeClr val="accent1"/>
+          </a:lnRef>
+          <a:fillRef idx="3">
+            <a:schemeClr val="accent1"/>
+          </a:fillRef>
+          <a:effectRef idx="2">
+            <a:schemeClr val="accent1"/>
+          </a:effectRef>
+          <a:fontRef idx="minor">
+            <a:schemeClr val="lt1"/>
+          </a:fontRef>
+        </p:style>
+        <p:txBody>
+          <a:bodyPr rtlCol="0" anchor="ctr"/>
+          <a:lstStyle/>
+          <a:p>
+            <a:pPr algn="ctr"/>
+          </a:p>
+        </p:txBody>
+      </p:sp>
+      <p:sp>
+        <p:nvSpPr>
+          <p:cNvPr id="23" name="TextBox 22"/>
+          <p:cNvSpPr txBox="1"/>
+          <p:nvPr/>
+        </p:nvSpPr>
+        <p:spPr>
+          <a:xfrm>
+            <a:off x="3616174" y="3264408"/>
+            <a:ext cx="777240" cy="219456"/>
+          </a:xfrm>
+          <a:prstGeom prst="rect">
+            <a:avLst/>
+          </a:prstGeom>
+          <a:noFill/>
+        </p:spPr>
+        <p:txBody>
+          <a:bodyPr wrap="square" lIns="0" rIns="0" tIns="0" bIns="0" anchor="t">
+            <a:spAutoFit/>
+          </a:bodyPr>
+          <a:lstStyle/>
+          <a:p>
+            <a:pPr algn="l"/>
+            <a:r>
+              <a:rPr sz="850" b="0" i="0">
+                <a:solidFill>
+                  <a:srgbClr val="D7DCE6"/>
+                </a:solidFill>
+                <a:latin typeface="Arial"/>
+              </a:rPr>
+              <a:t>24 %</a:t>
+            </a:r>
+          </a:p>
+        </p:txBody>
+      </p:sp>
+      <p:sp>
+        <p:nvSpPr>
+          <p:cNvPr id="24" name="Rectangle 23"/>
+          <p:cNvSpPr/>
+          <p:nvPr/>
+        </p:nvSpPr>
+        <p:spPr>
+          <a:xfrm>
+            <a:off x="1965960" y="3479292"/>
+            <a:ext cx="1045464" cy="141732"/>
+          </a:xfrm>
+          <a:prstGeom prst="rect">
+            <a:avLst/>
+          </a:prstGeom>
+          <a:solidFill>
+            <a:srgbClr val="47B25B"/>
+          </a:solidFill>
+          <a:ln>
+            <a:noFill/>
+          </a:ln>
+          <a:effectLst/>
+        </p:spPr>
+        <p:style>
+          <a:lnRef idx="1">
+            <a:schemeClr val="accent1"/>
+          </a:lnRef>
+          <a:fillRef idx="3">
+            <a:schemeClr val="accent1"/>
+          </a:fillRef>
+          <a:effectRef idx="2">
+            <a:schemeClr val="accent1"/>
+          </a:effectRef>
+          <a:fontRef idx="minor">
+            <a:schemeClr val="lt1"/>
+          </a:fontRef>
+        </p:style>
+        <p:txBody>
+          <a:bodyPr rtlCol="0" anchor="ctr"/>
+          <a:lstStyle/>
+          <a:p>
+            <a:pPr algn="ctr"/>
+          </a:p>
+        </p:txBody>
+      </p:sp>
+      <p:sp>
+        <p:nvSpPr>
+          <p:cNvPr id="25" name="TextBox 24"/>
+          <p:cNvSpPr txBox="1"/>
+          <p:nvPr/>
+        </p:nvSpPr>
+        <p:spPr>
+          <a:xfrm>
+            <a:off x="3066288" y="3451860"/>
+            <a:ext cx="777240" cy="219456"/>
+          </a:xfrm>
+          <a:prstGeom prst="rect">
+            <a:avLst/>
+          </a:prstGeom>
+          <a:noFill/>
+        </p:spPr>
+        <p:txBody>
+          <a:bodyPr wrap="square" lIns="0" rIns="0" tIns="0" bIns="0" anchor="t">
+            <a:spAutoFit/>
+          </a:bodyPr>
+          <a:lstStyle/>
+          <a:p>
+            <a:pPr algn="l"/>
+            <a:r>
+              <a:rPr sz="850" b="0" i="0">
+                <a:solidFill>
+                  <a:srgbClr val="D7DCE6"/>
+                </a:solidFill>
+                <a:latin typeface="Arial"/>
+              </a:rPr>
+              <a:t>15 %</a:t>
+            </a:r>
+          </a:p>
+        </p:txBody>
+      </p:sp>
+      <p:sp>
+        <p:nvSpPr>
+          <p:cNvPr id="26" name="TextBox 25"/>
+          <p:cNvSpPr txBox="1"/>
+          <p:nvPr/>
+        </p:nvSpPr>
+        <p:spPr>
+          <a:xfrm>
+            <a:off x="566928" y="3785615"/>
+            <a:ext cx="1325880" cy="274320"/>
+          </a:xfrm>
+          <a:prstGeom prst="rect">
+            <a:avLst/>
+          </a:prstGeom>
+          <a:noFill/>
+        </p:spPr>
+        <p:txBody>
+          <a:bodyPr wrap="square" lIns="0" rIns="0" tIns="0" bIns="0" anchor="t">
+            <a:spAutoFit/>
+          </a:bodyPr>
+          <a:lstStyle/>
+          <a:p>
+            <a:pPr algn="l"/>
+            <a:r>
+              <a:rPr sz="950" b="0" i="0">
+                <a:solidFill>
+                  <a:srgbClr val="FFFFFF"/>
+                </a:solidFill>
+                <a:latin typeface="Arial"/>
+              </a:rPr>
+              <a:t>Action</a:t>
+            </a:r>
+          </a:p>
+        </p:txBody>
+      </p:sp>
+      <p:sp>
+        <p:nvSpPr>
+          <p:cNvPr id="27" name="Rectangle 26"/>
+          <p:cNvSpPr/>
+          <p:nvPr/>
+        </p:nvSpPr>
+        <p:spPr>
+          <a:xfrm>
+            <a:off x="1965960" y="3767328"/>
+            <a:ext cx="1303435" cy="141732"/>
+          </a:xfrm>
+          <a:prstGeom prst="rect">
+            <a:avLst/>
+          </a:prstGeom>
+          <a:solidFill>
+            <a:srgbClr val="29A9E0"/>
+          </a:solidFill>
+          <a:ln>
+            <a:noFill/>
+          </a:ln>
+          <a:effectLst/>
+        </p:spPr>
+        <p:style>
+          <a:lnRef idx="1">
+            <a:schemeClr val="accent1"/>
+          </a:lnRef>
+          <a:fillRef idx="3">
+            <a:schemeClr val="accent1"/>
+          </a:fillRef>
+          <a:effectRef idx="2">
+            <a:schemeClr val="accent1"/>
+          </a:effectRef>
+          <a:fontRef idx="minor">
+            <a:schemeClr val="lt1"/>
+          </a:fontRef>
+        </p:style>
+        <p:txBody>
+          <a:bodyPr rtlCol="0" anchor="ctr"/>
+          <a:lstStyle/>
+          <a:p>
+            <a:pPr algn="ctr"/>
+          </a:p>
+        </p:txBody>
+      </p:sp>
+      <p:sp>
+        <p:nvSpPr>
+          <p:cNvPr id="28" name="TextBox 27"/>
+          <p:cNvSpPr txBox="1"/>
+          <p:nvPr/>
+        </p:nvSpPr>
+        <p:spPr>
+          <a:xfrm>
+            <a:off x="3324259" y="3739896"/>
+            <a:ext cx="777240" cy="219456"/>
+          </a:xfrm>
+          <a:prstGeom prst="rect">
+            <a:avLst/>
+          </a:prstGeom>
+          <a:noFill/>
+        </p:spPr>
+        <p:txBody>
+          <a:bodyPr wrap="square" lIns="0" rIns="0" tIns="0" bIns="0" anchor="t">
+            <a:spAutoFit/>
+          </a:bodyPr>
+          <a:lstStyle/>
+          <a:p>
+            <a:pPr algn="l"/>
+            <a:r>
+              <a:rPr sz="850" b="0" i="0">
+                <a:solidFill>
+                  <a:srgbClr val="D7DCE6"/>
+                </a:solidFill>
+                <a:latin typeface="Arial"/>
+              </a:rPr>
+              <a:t>19 %</a:t>
+            </a:r>
+          </a:p>
+        </p:txBody>
+      </p:sp>
+      <p:sp>
+        <p:nvSpPr>
+          <p:cNvPr id="29" name="Rectangle 28"/>
+          <p:cNvSpPr/>
+          <p:nvPr/>
+        </p:nvSpPr>
+        <p:spPr>
+          <a:xfrm>
+            <a:off x="1965960" y="3954780"/>
+            <a:ext cx="963999" cy="141732"/>
+          </a:xfrm>
+          <a:prstGeom prst="rect">
+            <a:avLst/>
+          </a:prstGeom>
+          <a:solidFill>
+            <a:srgbClr val="47B25B"/>
+          </a:solidFill>
+          <a:ln>
+            <a:noFill/>
+          </a:ln>
+          <a:effectLst/>
+        </p:spPr>
+        <p:style>
+          <a:lnRef idx="1">
+            <a:schemeClr val="accent1"/>
+          </a:lnRef>
+          <a:fillRef idx="3">
+            <a:schemeClr val="accent1"/>
+          </a:fillRef>
+          <a:effectRef idx="2">
+            <a:schemeClr val="accent1"/>
+          </a:effectRef>
+          <a:fontRef idx="minor">
+            <a:schemeClr val="lt1"/>
+          </a:fontRef>
+        </p:style>
+        <p:txBody>
+          <a:bodyPr rtlCol="0" anchor="ctr"/>
+          <a:lstStyle/>
+          <a:p>
+            <a:pPr algn="ctr"/>
+          </a:p>
+        </p:txBody>
+      </p:sp>
+      <p:sp>
+        <p:nvSpPr>
+          <p:cNvPr id="30" name="TextBox 29"/>
+          <p:cNvSpPr txBox="1"/>
+          <p:nvPr/>
+        </p:nvSpPr>
+        <p:spPr>
+          <a:xfrm>
+            <a:off x="2984823" y="3927348"/>
+            <a:ext cx="777240" cy="219456"/>
+          </a:xfrm>
+          <a:prstGeom prst="rect">
+            <a:avLst/>
+          </a:prstGeom>
+          <a:noFill/>
+        </p:spPr>
+        <p:txBody>
+          <a:bodyPr wrap="square" lIns="0" rIns="0" tIns="0" bIns="0" anchor="t">
+            <a:spAutoFit/>
+          </a:bodyPr>
+          <a:lstStyle/>
+          <a:p>
+            <a:pPr algn="l"/>
+            <a:r>
+              <a:rPr sz="850" b="0" i="0">
+                <a:solidFill>
+                  <a:srgbClr val="D7DCE6"/>
+                </a:solidFill>
+                <a:latin typeface="Arial"/>
+              </a:rPr>
+              <a:t>14 %</a:t>
+            </a:r>
+          </a:p>
+        </p:txBody>
+      </p:sp>
+      <p:sp>
+        <p:nvSpPr>
+          <p:cNvPr id="31" name="TextBox 30"/>
+          <p:cNvSpPr txBox="1"/>
+          <p:nvPr/>
+        </p:nvSpPr>
+        <p:spPr>
+          <a:xfrm>
+            <a:off x="566928" y="4261104"/>
+            <a:ext cx="822960" cy="201168"/>
+          </a:xfrm>
+          <a:prstGeom prst="rect">
+            <a:avLst/>
+          </a:prstGeom>
+          <a:noFill/>
+        </p:spPr>
+        <p:txBody>
+          <a:bodyPr wrap="square" lIns="0" rIns="0" tIns="0" bIns="0" anchor="t">
+            <a:spAutoFit/>
+          </a:bodyPr>
+          <a:lstStyle/>
+          <a:p>
+            <a:pPr algn="l"/>
+            <a:r>
+              <a:rPr sz="900" b="1" i="0">
+                <a:solidFill>
+                  <a:srgbClr val="29A9E0"/>
+                </a:solidFill>
+                <a:latin typeface="Arial"/>
+              </a:rPr>
+              <a:t>Mac</a:t>
+            </a:r>
+          </a:p>
+        </p:txBody>
+      </p:sp>
+      <p:sp>
+        <p:nvSpPr>
+          <p:cNvPr id="32" name="TextBox 31"/>
+          <p:cNvSpPr txBox="1"/>
+          <p:nvPr/>
+        </p:nvSpPr>
+        <p:spPr>
+          <a:xfrm>
+            <a:off x="1417320" y="4261104"/>
+            <a:ext cx="822960" cy="201168"/>
+          </a:xfrm>
+          <a:prstGeom prst="rect">
+            <a:avLst/>
+          </a:prstGeom>
+          <a:noFill/>
+        </p:spPr>
+        <p:txBody>
+          <a:bodyPr wrap="square" lIns="0" rIns="0" tIns="0" bIns="0" anchor="t">
+            <a:spAutoFit/>
+          </a:bodyPr>
+          <a:lstStyle/>
+          <a:p>
+            <a:pPr algn="l"/>
+            <a:r>
+              <a:rPr sz="900" b="1" i="0">
+                <a:solidFill>
+                  <a:srgbClr val="47B25B"/>
+                </a:solidFill>
+                <a:latin typeface="Arial"/>
+              </a:rPr>
+              <a:t>Linux</a:t>
+            </a:r>
+          </a:p>
+        </p:txBody>
+      </p:sp>
+      <p:sp>
+        <p:nvSpPr>
+          <p:cNvPr id="33" name="Rounded Rectangle 32"/>
+          <p:cNvSpPr/>
+          <p:nvPr/>
+        </p:nvSpPr>
+        <p:spPr>
+          <a:xfrm>
+            <a:off x="5440680" y="1645920"/>
+            <a:ext cx="3246120" cy="896112"/>
+          </a:xfrm>
+          <a:prstGeom prst="roundRect">
+            <a:avLst>
+              <a:gd name="adj" fmla="val 10000"/>
+            </a:avLst>
+          </a:prstGeom>
+          <a:solidFill>
+            <a:srgbClr val="14243C"/>
+          </a:solidFill>
+          <a:ln w="15240">
+            <a:solidFill>
+              <a:srgbClr val="29A9E0"/>
+            </a:solidFill>
+          </a:ln>
+          <a:effectLst/>
+        </p:spPr>
+        <p:style>
+          <a:lnRef idx="1">
+            <a:schemeClr val="accent1"/>
+          </a:lnRef>
+          <a:fillRef idx="3">
+            <a:schemeClr val="accent1"/>
+          </a:fillRef>
+          <a:effectRef idx="2">
+            <a:schemeClr val="accent1"/>
+          </a:effectRef>
+          <a:fontRef idx="minor">
+            <a:schemeClr val="lt1"/>
+          </a:fontRef>
+        </p:style>
+        <p:txBody>
+          <a:bodyPr rtlCol="0" anchor="ctr"/>
+          <a:lstStyle/>
+          <a:p>
+            <a:pPr algn="ctr"/>
+          </a:p>
+        </p:txBody>
+      </p:sp>
+      <p:sp>
+        <p:nvSpPr>
+          <p:cNvPr id="34" name="TextBox 33"/>
+          <p:cNvSpPr txBox="1"/>
+          <p:nvPr/>
+        </p:nvSpPr>
+        <p:spPr>
+          <a:xfrm>
+            <a:off x="5577840" y="1805940"/>
+            <a:ext cx="1691639" cy="256032"/>
+          </a:xfrm>
+          <a:prstGeom prst="rect">
+            <a:avLst/>
+          </a:prstGeom>
+          <a:noFill/>
+        </p:spPr>
+        <p:txBody>
+          <a:bodyPr wrap="square" lIns="0" rIns="0" tIns="0" bIns="0" anchor="t">
+            <a:spAutoFit/>
+          </a:bodyPr>
+          <a:lstStyle/>
+          <a:p>
+            <a:pPr algn="l"/>
+            <a:r>
+              <a:rPr sz="1050" b="1" i="0">
+                <a:solidFill>
+                  <a:srgbClr val="29A9E0"/>
+                </a:solidFill>
+                <a:latin typeface="Arial"/>
+              </a:rPr>
+              <a:t>Windows</a:t>
+            </a:r>
+          </a:p>
+        </p:txBody>
+      </p:sp>
+      <p:sp>
+        <p:nvSpPr>
+          <p:cNvPr id="35" name="TextBox 34"/>
+          <p:cNvSpPr txBox="1"/>
+          <p:nvPr/>
+        </p:nvSpPr>
+        <p:spPr>
+          <a:xfrm>
+            <a:off x="5577840" y="2061972"/>
+            <a:ext cx="1691639" cy="237744"/>
+          </a:xfrm>
+          <a:prstGeom prst="rect">
+            <a:avLst/>
+          </a:prstGeom>
+          <a:noFill/>
+        </p:spPr>
+        <p:txBody>
+          <a:bodyPr wrap="square" lIns="0" rIns="0" tIns="0" bIns="0" anchor="t">
+            <a:spAutoFit/>
+          </a:bodyPr>
+          <a:lstStyle/>
+          <a:p>
+            <a:pPr algn="l"/>
+            <a:r>
+              <a:rPr sz="900" b="0" i="0">
+                <a:solidFill>
+                  <a:srgbClr val="9AA3B2"/>
+                </a:solidFill>
+                <a:latin typeface="Arial"/>
+              </a:rPr>
+              <a:t>Universel, quel que soit le genre</a:t>
+            </a:r>
+          </a:p>
+        </p:txBody>
+      </p:sp>
+      <p:sp>
+        <p:nvSpPr>
+          <p:cNvPr id="36" name="TextBox 35"/>
+          <p:cNvSpPr txBox="1"/>
+          <p:nvPr/>
+        </p:nvSpPr>
+        <p:spPr>
+          <a:xfrm>
+            <a:off x="7132320" y="1842516"/>
+            <a:ext cx="1417320" cy="411480"/>
+          </a:xfrm>
+          <a:prstGeom prst="rect">
+            <a:avLst/>
+          </a:prstGeom>
+          <a:noFill/>
+        </p:spPr>
+        <p:txBody>
+          <a:bodyPr wrap="square" lIns="0" rIns="0" tIns="0" bIns="0" anchor="t">
+            <a:spAutoFit/>
+          </a:bodyPr>
+          <a:lstStyle/>
+          <a:p>
+            <a:pPr algn="r"/>
+            <a:r>
+              <a:rPr sz="1700" b="1" i="0">
+                <a:solidFill>
+                  <a:srgbClr val="29A9E0"/>
+                </a:solidFill>
+                <a:latin typeface="Arial Black"/>
+              </a:rPr>
+              <a:t>100%</a:t>
+            </a:r>
+          </a:p>
+        </p:txBody>
+      </p:sp>
+      <p:sp>
+        <p:nvSpPr>
+          <p:cNvPr id="37" name="Rounded Rectangle 36"/>
+          <p:cNvSpPr/>
+          <p:nvPr/>
+        </p:nvSpPr>
+        <p:spPr>
+          <a:xfrm>
+            <a:off x="5440680" y="2651760"/>
+            <a:ext cx="3246120" cy="896112"/>
+          </a:xfrm>
+          <a:prstGeom prst="roundRect">
+            <a:avLst>
+              <a:gd name="adj" fmla="val 10000"/>
+            </a:avLst>
+          </a:prstGeom>
+          <a:solidFill>
+            <a:srgbClr val="14243C"/>
+          </a:solidFill>
+          <a:ln w="15240">
+            <a:solidFill>
+              <a:srgbClr val="F2C719"/>
+            </a:solidFill>
+          </a:ln>
+          <a:effectLst/>
+        </p:spPr>
+        <p:style>
+          <a:lnRef idx="1">
+            <a:schemeClr val="accent1"/>
+          </a:lnRef>
+          <a:fillRef idx="3">
+            <a:schemeClr val="accent1"/>
+          </a:fillRef>
+          <a:effectRef idx="2">
+            <a:schemeClr val="accent1"/>
+          </a:effectRef>
+          <a:fontRef idx="minor">
+            <a:schemeClr val="lt1"/>
+          </a:fontRef>
+        </p:style>
+        <p:txBody>
+          <a:bodyPr rtlCol="0" anchor="ctr"/>
+          <a:lstStyle/>
+          <a:p>
+            <a:pPr algn="ctr"/>
+          </a:p>
+        </p:txBody>
+      </p:sp>
+      <p:sp>
+        <p:nvSpPr>
+          <p:cNvPr id="38" name="TextBox 37"/>
+          <p:cNvSpPr txBox="1"/>
+          <p:nvPr/>
+        </p:nvSpPr>
+        <p:spPr>
+          <a:xfrm>
+            <a:off x="5577840" y="2811779"/>
+            <a:ext cx="1691639" cy="256032"/>
+          </a:xfrm>
+          <a:prstGeom prst="rect">
+            <a:avLst/>
+          </a:prstGeom>
+          <a:noFill/>
+        </p:spPr>
+        <p:txBody>
+          <a:bodyPr wrap="square" lIns="0" rIns="0" tIns="0" bIns="0" anchor="t">
+            <a:spAutoFit/>
+          </a:bodyPr>
+          <a:lstStyle/>
+          <a:p>
+            <a:pPr algn="l"/>
+            <a:r>
+              <a:rPr sz="1050" b="1" i="0">
+                <a:solidFill>
+                  <a:srgbClr val="F2C719"/>
+                </a:solidFill>
+                <a:latin typeface="Arial"/>
+              </a:rPr>
+              <a:t>Mac</a:t>
+            </a:r>
+          </a:p>
+        </p:txBody>
+      </p:sp>
+      <p:sp>
+        <p:nvSpPr>
+          <p:cNvPr id="39" name="TextBox 38"/>
+          <p:cNvSpPr txBox="1"/>
+          <p:nvPr/>
+        </p:nvSpPr>
+        <p:spPr>
+          <a:xfrm>
+            <a:off x="5577840" y="3067811"/>
+            <a:ext cx="1691639" cy="237744"/>
+          </a:xfrm>
+          <a:prstGeom prst="rect">
+            <a:avLst/>
+          </a:prstGeom>
+          <a:noFill/>
+        </p:spPr>
+        <p:txBody>
+          <a:bodyPr wrap="square" lIns="0" rIns="0" tIns="0" bIns="0" anchor="t">
+            <a:spAutoFit/>
+          </a:bodyPr>
+          <a:lstStyle/>
+          <a:p>
+            <a:pPr algn="l"/>
+            <a:r>
+              <a:rPr sz="900" b="0" i="0">
+                <a:solidFill>
+                  <a:srgbClr val="9AA3B2"/>
+                </a:solidFill>
+                <a:latin typeface="Arial"/>
+              </a:rPr>
+              <a:t>Plus fort sur Strategy et Game Dev</a:t>
+            </a:r>
+          </a:p>
+        </p:txBody>
+      </p:sp>
+      <p:sp>
+        <p:nvSpPr>
+          <p:cNvPr id="40" name="TextBox 39"/>
+          <p:cNvSpPr txBox="1"/>
+          <p:nvPr/>
+        </p:nvSpPr>
+        <p:spPr>
+          <a:xfrm>
+            <a:off x="7132320" y="2848356"/>
+            <a:ext cx="1417320" cy="411480"/>
+          </a:xfrm>
+          <a:prstGeom prst="rect">
+            <a:avLst/>
+          </a:prstGeom>
+          <a:noFill/>
+        </p:spPr>
+        <p:txBody>
+          <a:bodyPr wrap="square" lIns="0" rIns="0" tIns="0" bIns="0" anchor="t">
+            <a:spAutoFit/>
+          </a:bodyPr>
+          <a:lstStyle/>
+          <a:p>
+            <a:pPr algn="r"/>
+            <a:r>
+              <a:rPr sz="1700" b="1" i="0">
+                <a:solidFill>
+                  <a:srgbClr val="F2C719"/>
+                </a:solidFill>
+                <a:latin typeface="Arial Black"/>
+              </a:rPr>
+              <a:t>19-33%</a:t>
+            </a:r>
+          </a:p>
+        </p:txBody>
+      </p:sp>
+      <p:sp>
+        <p:nvSpPr>
+          <p:cNvPr id="41" name="Rounded Rectangle 40"/>
+          <p:cNvSpPr/>
+          <p:nvPr/>
+        </p:nvSpPr>
+        <p:spPr>
+          <a:xfrm>
+            <a:off x="5440680" y="3657600"/>
+            <a:ext cx="3246120" cy="896112"/>
+          </a:xfrm>
+          <a:prstGeom prst="roundRect">
+            <a:avLst>
+              <a:gd name="adj" fmla="val 10000"/>
+            </a:avLst>
+          </a:prstGeom>
+          <a:solidFill>
+            <a:srgbClr val="14243C"/>
+          </a:solidFill>
+          <a:ln w="15240">
+            <a:solidFill>
+              <a:srgbClr val="47B25B"/>
+            </a:solidFill>
+          </a:ln>
+          <a:effectLst/>
+        </p:spPr>
+        <p:style>
+          <a:lnRef idx="1">
+            <a:schemeClr val="accent1"/>
+          </a:lnRef>
+          <a:fillRef idx="3">
+            <a:schemeClr val="accent1"/>
+          </a:fillRef>
+          <a:effectRef idx="2">
+            <a:schemeClr val="accent1"/>
+          </a:effectRef>
+          <a:fontRef idx="minor">
+            <a:schemeClr val="lt1"/>
+          </a:fontRef>
+        </p:style>
+        <p:txBody>
+          <a:bodyPr rtlCol="0" anchor="ctr"/>
+          <a:lstStyle/>
+          <a:p>
+            <a:pPr algn="ctr"/>
+          </a:p>
+        </p:txBody>
+      </p:sp>
+      <p:sp>
+        <p:nvSpPr>
+          <p:cNvPr id="42" name="TextBox 41"/>
+          <p:cNvSpPr txBox="1"/>
+          <p:nvPr/>
+        </p:nvSpPr>
+        <p:spPr>
+          <a:xfrm>
+            <a:off x="5577840" y="3817620"/>
+            <a:ext cx="1691639" cy="256032"/>
+          </a:xfrm>
+          <a:prstGeom prst="rect">
+            <a:avLst/>
+          </a:prstGeom>
+          <a:noFill/>
+        </p:spPr>
+        <p:txBody>
+          <a:bodyPr wrap="square" lIns="0" rIns="0" tIns="0" bIns="0" anchor="t">
+            <a:spAutoFit/>
+          </a:bodyPr>
+          <a:lstStyle/>
+          <a:p>
+            <a:pPr algn="l"/>
+            <a:r>
+              <a:rPr sz="1050" b="1" i="0">
+                <a:solidFill>
+                  <a:srgbClr val="47B25B"/>
+                </a:solidFill>
+                <a:latin typeface="Arial"/>
+              </a:rPr>
+              <a:t>Linux</a:t>
+            </a:r>
+          </a:p>
+        </p:txBody>
+      </p:sp>
+      <p:sp>
+        <p:nvSpPr>
+          <p:cNvPr id="43" name="TextBox 42"/>
+          <p:cNvSpPr txBox="1"/>
+          <p:nvPr/>
+        </p:nvSpPr>
+        <p:spPr>
+          <a:xfrm>
+            <a:off x="5577840" y="4073652"/>
+            <a:ext cx="1691639" cy="237744"/>
+          </a:xfrm>
+          <a:prstGeom prst="rect">
+            <a:avLst/>
+          </a:prstGeom>
+          <a:noFill/>
+        </p:spPr>
+        <p:txBody>
+          <a:bodyPr wrap="square" lIns="0" rIns="0" tIns="0" bIns="0" anchor="t">
+            <a:spAutoFit/>
+          </a:bodyPr>
+          <a:lstStyle/>
+          <a:p>
+            <a:pPr algn="l"/>
+            <a:r>
+              <a:rPr sz="900" b="0" i="0">
+                <a:solidFill>
+                  <a:srgbClr val="9AA3B2"/>
+                </a:solidFill>
+                <a:latin typeface="Arial"/>
+              </a:rPr>
+              <a:t>Niche fidèle, surtout Indie</a:t>
+            </a:r>
+          </a:p>
+        </p:txBody>
+      </p:sp>
+      <p:sp>
+        <p:nvSpPr>
+          <p:cNvPr id="44" name="TextBox 43"/>
+          <p:cNvSpPr txBox="1"/>
+          <p:nvPr/>
+        </p:nvSpPr>
+        <p:spPr>
+          <a:xfrm>
+            <a:off x="7132320" y="3854196"/>
+            <a:ext cx="1417320" cy="411480"/>
+          </a:xfrm>
+          <a:prstGeom prst="rect">
+            <a:avLst/>
+          </a:prstGeom>
+          <a:noFill/>
+        </p:spPr>
+        <p:txBody>
+          <a:bodyPr wrap="square" lIns="0" rIns="0" tIns="0" bIns="0" anchor="t">
+            <a:spAutoFit/>
+          </a:bodyPr>
+          <a:lstStyle/>
+          <a:p>
+            <a:pPr algn="r"/>
+            <a:r>
+              <a:rPr sz="1700" b="1" i="0">
+                <a:solidFill>
+                  <a:srgbClr val="47B25B"/>
+                </a:solidFill>
+                <a:latin typeface="Arial Black"/>
+              </a:rPr>
+              <a:t>14-22%</a:t>
+            </a:r>
+          </a:p>
+        </p:txBody>
+      </p:sp>
+      <p:sp>
+        <p:nvSpPr>
+          <p:cNvPr id="45" name="TextBox 44"/>
+          <p:cNvSpPr txBox="1"/>
+          <p:nvPr/>
+        </p:nvSpPr>
+        <p:spPr>
+          <a:xfrm>
+            <a:off x="457200" y="4736592"/>
+            <a:ext cx="8229600" cy="320040"/>
+          </a:xfrm>
+          <a:prstGeom prst="rect">
+            <a:avLst/>
+          </a:prstGeom>
+          <a:noFill/>
+        </p:spPr>
+        <p:txBody>
+          <a:bodyPr wrap="square" lIns="0" rIns="0" tIns="0" bIns="0" anchor="t">
+            <a:spAutoFit/>
+          </a:bodyPr>
+          <a:lstStyle/>
+          <a:p>
+            <a:pPr algn="l"/>
+            <a:r>
+              <a:rPr sz="1000" b="0" i="1">
+                <a:solidFill>
+                  <a:srgbClr val="29A9E0"/>
+                </a:solidFill>
+                <a:latin typeface="Arial"/>
+              </a:rPr>
+              <a:t>Insight : Windows est incontournable partout. Le support Mac et Linux dépend du genre - plus élevé sur la stratégie, plus faible sur l'Action.</a:t>
+            </a:r>
+          </a:p>
+        </p:txBody>
+      </p:sp>
     </p:spTree>
   </p:cSld>
   <p:clrMapOvr>
@@ -2992,7 +7367,7 @@
                 <a:ea typeface="Arial" pitchFamily="34" charset="-122"/>
                 <a:cs typeface="Arial" pitchFamily="34" charset="-120"/>
               </a:rPr>
-              <a:t>A N A L Y S E   M A C R O   -   1 / 3</a:t>
+              <a:t>A N A L Y S E   M A C R O   -   1 / 5</a:t>
             </a:r>
             <a:endParaRPr lang="en-US" sz="1100" dirty="0"/>
           </a:p>
@@ -4801,7 +9176,7 @@
                 <a:ea typeface="Arial" pitchFamily="34" charset="-122"/>
                 <a:cs typeface="Arial" pitchFamily="34" charset="-120"/>
               </a:rPr>
-              <a:t>A N A L Y S E   M A C R O   -   2 / 3</a:t>
+              <a:t>A N A L Y S E   M A C R O   -   3 / 5</a:t>
             </a:r>
             <a:endParaRPr lang="en-US" sz="1100" dirty="0"/>
           </a:p>
@@ -6712,7 +11087,7 @@
                 <a:ea typeface="Arial" pitchFamily="34" charset="-122"/>
                 <a:cs typeface="Arial" pitchFamily="34" charset="-120"/>
               </a:rPr>
-              <a:t>A N A L Y S E   M A C R O   -   3 / 3</a:t>
+              <a:t>A N A L Y S E   M A C R O   -   5 / 5</a:t>
             </a:r>
             <a:endParaRPr lang="en-US" sz="1100" dirty="0"/>
           </a:p>
@@ -6751,7 +11126,7 @@
                 <a:ea typeface="Arial Black" pitchFamily="34" charset="-122"/>
                 <a:cs typeface="Arial Black" pitchFamily="34" charset="-120"/>
               </a:rPr>
-              <a:t>Prix et Langues</a:t>
+              <a:t>Langues et Âge</a:t>
             </a:r>
             <a:endParaRPr lang="en-US" sz="3400" dirty="0"/>
           </a:p>
@@ -8540,6 +12915,10 @@
             <a:prstDash val="solid"/>
           </a:ln>
         </p:spPr>
+        <p:txBody>
+          <a:bodyPr/>
+          <a:p/>
+        </p:txBody>
       </p:sp>
       <p:sp>
         <p:nvSpPr>
@@ -8563,6 +12942,10 @@
             <a:prstDash val="solid"/>
           </a:ln>
         </p:spPr>
+        <p:txBody>
+          <a:bodyPr/>
+          <a:p/>
+        </p:txBody>
       </p:sp>
       <p:sp>
         <p:nvSpPr>
@@ -8625,6 +13008,10 @@
             <a:prstDash val="solid"/>
           </a:ln>
         </p:spPr>
+        <p:txBody>
+          <a:bodyPr/>
+          <a:p/>
+        </p:txBody>
       </p:sp>
       <p:sp>
         <p:nvSpPr>
@@ -8687,6 +13074,10 @@
             <a:prstDash val="solid"/>
           </a:ln>
         </p:spPr>
+        <p:txBody>
+          <a:bodyPr/>
+          <a:p/>
+        </p:txBody>
       </p:sp>
       <p:sp>
         <p:nvSpPr>
@@ -8749,6 +13140,10 @@
             <a:prstDash val="solid"/>
           </a:ln>
         </p:spPr>
+        <p:txBody>
+          <a:bodyPr/>
+          <a:p/>
+        </p:txBody>
       </p:sp>
       <p:sp>
         <p:nvSpPr>
@@ -8811,6 +13206,10 @@
             <a:prstDash val="solid"/>
           </a:ln>
         </p:spPr>
+        <p:txBody>
+          <a:bodyPr/>
+          <a:p/>
+        </p:txBody>
       </p:sp>
       <p:sp>
         <p:nvSpPr>
@@ -8909,6 +13308,10 @@
           </a:solidFill>
           <a:ln/>
         </p:spPr>
+        <p:txBody>
+          <a:bodyPr/>
+          <a:p/>
+        </p:txBody>
       </p:sp>
       <p:sp>
         <p:nvSpPr>
@@ -9007,6 +13410,10 @@
           </a:solidFill>
           <a:ln/>
         </p:spPr>
+        <p:txBody>
+          <a:bodyPr/>
+          <a:p/>
+        </p:txBody>
       </p:sp>
       <p:sp>
         <p:nvSpPr>
@@ -9105,6 +13512,10 @@
           </a:solidFill>
           <a:ln/>
         </p:spPr>
+        <p:txBody>
+          <a:bodyPr/>
+          <a:p/>
+        </p:txBody>
       </p:sp>
       <p:sp>
         <p:nvSpPr>
@@ -9203,6 +13614,10 @@
           </a:solidFill>
           <a:ln/>
         </p:spPr>
+        <p:txBody>
+          <a:bodyPr/>
+          <a:p/>
+        </p:txBody>
       </p:sp>
       <p:sp>
         <p:nvSpPr>
@@ -9301,6 +13716,10 @@
           </a:solidFill>
           <a:ln/>
         </p:spPr>
+        <p:txBody>
+          <a:bodyPr/>
+          <a:p/>
+        </p:txBody>
       </p:sp>
       <p:sp>
         <p:nvSpPr>
@@ -9399,6 +13818,10 @@
           </a:solidFill>
           <a:ln/>
         </p:spPr>
+        <p:txBody>
+          <a:bodyPr/>
+          <a:p/>
+        </p:txBody>
       </p:sp>
       <p:sp>
         <p:nvSpPr>
@@ -9497,6 +13920,10 @@
           </a:solidFill>
           <a:ln/>
         </p:spPr>
+        <p:txBody>
+          <a:bodyPr/>
+          <a:p/>
+        </p:txBody>
       </p:sp>
       <p:sp>
         <p:nvSpPr>
@@ -9563,6 +13990,10 @@
             <a:prstDash val="solid"/>
           </a:ln>
         </p:spPr>
+        <p:txBody>
+          <a:bodyPr/>
+          <a:p/>
+        </p:txBody>
       </p:sp>
       <p:sp>
         <p:nvSpPr>
@@ -9707,6 +14138,10 @@
             <a:prstDash val="solid"/>
           </a:ln>
         </p:spPr>
+        <p:txBody>
+          <a:bodyPr/>
+          <a:p/>
+        </p:txBody>
       </p:sp>
       <p:sp>
         <p:nvSpPr>
@@ -9780,7 +14215,7 @@
                 <a:ea typeface="Arial" pitchFamily="34" charset="-122"/>
                 <a:cs typeface="Arial" pitchFamily="34" charset="-120"/>
               </a:rPr>
-              <a:t>3 milliards</a:t>
+              <a:t>2,9 milliards</a:t>
             </a:r>
             <a:endParaRPr lang="en-US" sz="1600" dirty="0"/>
           </a:p>
@@ -10066,7 +14501,7 @@
                 <a:ea typeface="Arial" pitchFamily="34" charset="-122"/>
                 <a:cs typeface="Arial" pitchFamily="34" charset="-120"/>
               </a:rPr>
-              <a:t>A N A L Y S E   D E S   P L A T E F O R M E S</a:t>
+              <a:t>A N A L Y S E   D E S   P L A T E F O R M E S   -   1 / 2</a:t>
             </a:r>
             <a:endParaRPr lang="en-US" sz="1100" dirty="0"/>
           </a:p>
@@ -11464,6 +15899,10 @@
             <a:prstDash val="solid"/>
           </a:ln>
         </p:spPr>
+        <p:txBody>
+          <a:bodyPr/>
+          <a:p/>
+        </p:txBody>
       </p:sp>
       <p:sp>
         <p:nvSpPr>
@@ -11484,6 +15923,10 @@
           </a:solidFill>
           <a:ln/>
         </p:spPr>
+        <p:txBody>
+          <a:bodyPr/>
+          <a:p/>
+        </p:txBody>
       </p:sp>
       <p:sp>
         <p:nvSpPr>
@@ -11599,7 +16042,7 @@
                 <a:ea typeface="Arial" pitchFamily="34" charset="-122"/>
                 <a:cs typeface="Arial" pitchFamily="34" charset="-120"/>
               </a:rPr>
-              <a:t>Le plus lucratif : environ 3 milliards de propriétaires.</a:t>
+              <a:t>Le plus lucratif : environ 2,9 milliards de propriétaires.</a:t>
             </a:r>
             <a:endParaRPr lang="en-US" sz="950" dirty="0"/>
           </a:p>
@@ -11669,6 +16112,10 @@
             <a:prstDash val="solid"/>
           </a:ln>
         </p:spPr>
+        <p:txBody>
+          <a:bodyPr/>
+          <a:p/>
+        </p:txBody>
       </p:sp>
       <p:sp>
         <p:nvSpPr>
@@ -11689,6 +16136,10 @@
           </a:solidFill>
           <a:ln/>
         </p:spPr>
+        <p:txBody>
+          <a:bodyPr/>
+          <a:p/>
+        </p:txBody>
       </p:sp>
       <p:sp>
         <p:nvSpPr>
@@ -11874,6 +16325,10 @@
             <a:prstDash val="solid"/>
           </a:ln>
         </p:spPr>
+        <p:txBody>
+          <a:bodyPr/>
+          <a:p/>
+        </p:txBody>
       </p:sp>
       <p:sp>
         <p:nvSpPr>
@@ -11894,6 +16349,10 @@
           </a:solidFill>
           <a:ln/>
         </p:spPr>
+        <p:txBody>
+          <a:bodyPr/>
+          <a:p/>
+        </p:txBody>
       </p:sp>
       <p:sp>
         <p:nvSpPr>
@@ -12001,37 +16460,37 @@
               <a:buNone/>
             </a:pPr>
             <a:r>
-              <a:rPr lang="en-US" sz="950" dirty="0">
+              <a:rPr sz="950">
                 <a:solidFill>
                   <a:srgbClr val="D7DCE6"/>
                 </a:solidFill>
-                <a:latin typeface="Arial" pitchFamily="34" charset="0"/>
-                <a:ea typeface="Arial" pitchFamily="34" charset="-122"/>
-                <a:cs typeface="Arial" pitchFamily="34" charset="-120"/>
-              </a:rPr>
-              <a:t>Zone optimale du marché Steam.</a:t>
+                <a:latin typeface="Arial"/>
+              </a:rPr>
+              <a:t>Le marché se concentre sous 10 euros (médiane 5,99 €).</a:t>
             </a:r>
             <a:endParaRPr lang="en-US" sz="950" dirty="0"/>
           </a:p>
           <a:p>
-            <a:pPr indent="0" marL="0">
-              <a:lnSpc>
-                <a:spcPct val="105000"/>
-              </a:lnSpc>
-              <a:buNone/>
-            </a:pPr>
-            <a:r>
-              <a:rPr lang="en-US" sz="950" dirty="0">
+            <a:r>
+              <a:rPr sz="950">
                 <a:solidFill>
                   <a:srgbClr val="D7DCE6"/>
                 </a:solidFill>
-                <a:latin typeface="Arial" pitchFamily="34" charset="0"/>
-                <a:ea typeface="Arial" pitchFamily="34" charset="-122"/>
-                <a:cs typeface="Arial" pitchFamily="34" charset="-120"/>
-              </a:rPr>
-              <a:t>Éviter moins de 5 euros (dévaluation) et plus de 50 euros (frein pour une nouvelle IP).</a:t>
-            </a:r>
-            <a:endParaRPr lang="en-US" sz="950" dirty="0"/>
+                <a:latin typeface="Arial"/>
+              </a:rPr>
+              <a:t>Se positionner juste au-dessus du segment saturé,</a:t>
+            </a:r>
+          </a:p>
+          <a:p>
+            <a:r>
+              <a:rPr sz="950">
+                <a:solidFill>
+                  <a:srgbClr val="D7DCE6"/>
+                </a:solidFill>
+                <a:latin typeface="Arial"/>
+              </a:rPr>
+              <a:t>tout en restant sous 20 euros comme 93 % des jeux.</a:t>
+            </a:r>
           </a:p>
         </p:txBody>
       </p:sp>
@@ -12059,6 +16518,10 @@
             <a:prstDash val="solid"/>
           </a:ln>
         </p:spPr>
+        <p:txBody>
+          <a:bodyPr/>
+          <a:p/>
+        </p:txBody>
       </p:sp>
       <p:sp>
         <p:nvSpPr>
@@ -12079,6 +16542,10 @@
           </a:solidFill>
           <a:ln/>
         </p:spPr>
+        <p:txBody>
+          <a:bodyPr/>
+          <a:p/>
+        </p:txBody>
       </p:sp>
       <p:sp>
         <p:nvSpPr>

</xml_diff>